<commit_message>
docs: unificar apresentacao profissional do UniGuard
</commit_message>
<xml_diff>
--- a/UniGuard_Apresentacao_Profissional_Atualizada.pptx
+++ b/UniGuard_Apresentacao_Profissional_Atualizada.pptx
@@ -20,6 +20,9 @@
     <p:sldId xmlns:r="http://schemas.openxmlformats.org/officeDocument/2006/relationships" id="265" r:id="Ra89f47f0be504e3a"/>
     <p:sldId xmlns:r="http://schemas.openxmlformats.org/officeDocument/2006/relationships" id="266" r:id="R854d37cb979a4a41"/>
     <p:sldId xmlns:r="http://schemas.openxmlformats.org/officeDocument/2006/relationships" id="267" r:id="R7c053332f14e445a"/>
+    <p:sldId xmlns:ns0="http://schemas.openxmlformats.org/officeDocument/2006/relationships" id="268" ns0:id="rId19"/>
+    <p:sldId xmlns:ns0="http://schemas.openxmlformats.org/officeDocument/2006/relationships" id="269" ns0:id="rId20"/>
+    <p:sldId xmlns:ns0="http://schemas.openxmlformats.org/officeDocument/2006/relationships" id="270" ns0:id="rId21"/>
   </p:sldIdLst>
   <p:sldSz cx="12191695" cy="6858000"/>
   <p:notesSz cx="6858000" cy="9144000"/>
@@ -6750,19 +6753,8 @@
           </a:bodyPr>
           <a:lstStyle xmlns:a="http://schemas.openxmlformats.org/drawingml/2006/main"/>
           <a:p xmlns:a="http://schemas.openxmlformats.org/drawingml/2006/main">
-            <a:pPr algn="ctr">
-              <a:buNone/>
-              <a:defRPr sz="1600" b="1">
-                <a:solidFill>
-                  <a:srgbClr val="17233A"/>
-                </a:solidFill>
-                <a:latin typeface="Aptos"/>
-                <a:ea typeface="Aptos"/>
-                <a:cs typeface="Aptos"/>
-              </a:defRPr>
-            </a:pPr>
-            <a:r>
-              <a:t>MVP conectado</a:t>
+            <a:r>
+              <a:t>MVP demonstrativo</a:t>
             </a:r>
           </a:p>
         </p:txBody>
@@ -6797,19 +6789,8 @@
           </a:bodyPr>
           <a:lstStyle xmlns:a="http://schemas.openxmlformats.org/drawingml/2006/main"/>
           <a:p xmlns:a="http://schemas.openxmlformats.org/drawingml/2006/main">
-            <a:pPr algn="ctr">
-              <a:buNone/>
-              <a:defRPr sz="1100" b="0">
-                <a:solidFill>
-                  <a:srgbClr val="60728A"/>
-                </a:solidFill>
-                <a:latin typeface="Aptos"/>
-                <a:ea typeface="Aptos"/>
-                <a:cs typeface="Aptos"/>
-              </a:defRPr>
-            </a:pPr>
-            <a:r>
-              <a:t>Fluxo SOS + Firebase + painel</a:t>
+            <a:r>
+              <a:t>Fluxo SOS + controles + painel</a:t>
             </a:r>
           </a:p>
         </p:txBody>
@@ -7048,19 +7029,8 @@
           </a:bodyPr>
           <a:lstStyle xmlns:a="http://schemas.openxmlformats.org/drawingml/2006/main"/>
           <a:p xmlns:a="http://schemas.openxmlformats.org/drawingml/2006/main">
-            <a:pPr algn="ctr">
-              <a:buNone/>
-              <a:defRPr sz="1600" b="1">
-                <a:solidFill>
-                  <a:srgbClr val="17233A"/>
-                </a:solidFill>
-                <a:latin typeface="Aptos"/>
-                <a:ea typeface="Aptos"/>
-                <a:cs typeface="Aptos"/>
-              </a:defRPr>
-            </a:pPr>
-            <a:r>
-              <a:t>Pesquisa e piloto</a:t>
+            <a:r>
+              <a:t>Validação integrada</a:t>
             </a:r>
           </a:p>
         </p:txBody>
@@ -7095,19 +7065,8 @@
           </a:bodyPr>
           <a:lstStyle xmlns:a="http://schemas.openxmlformats.org/drawingml/2006/main"/>
           <a:p xmlns:a="http://schemas.openxmlformats.org/drawingml/2006/main">
-            <a:pPr algn="ctr">
-              <a:buNone/>
-              <a:defRPr sz="1100" b="0">
-                <a:solidFill>
-                  <a:srgbClr val="60728A"/>
-                </a:solidFill>
-                <a:latin typeface="Aptos"/>
-                <a:ea typeface="Aptos"/>
-                <a:cs typeface="Aptos"/>
-              </a:defRPr>
-            </a:pPr>
-            <a:r>
-              <a:t>Questionário, cenários e testes com usuários</a:t>
+            <a:r>
+              <a:t>Testes Android → Firebase → Central, isolamento e abuso</a:t>
             </a:r>
           </a:p>
         </p:txBody>
@@ -7393,19 +7352,8 @@
           </a:bodyPr>
           <a:lstStyle xmlns:a="http://schemas.openxmlformats.org/drawingml/2006/main"/>
           <a:p xmlns:a="http://schemas.openxmlformats.org/drawingml/2006/main">
-            <a:pPr algn="ctr">
-              <a:buNone/>
-              <a:defRPr sz="1100" b="0">
-                <a:solidFill>
-                  <a:srgbClr val="60728A"/>
-                </a:solidFill>
-                <a:latin typeface="Aptos"/>
-                <a:ea typeface="Aptos"/>
-                <a:cs typeface="Aptos"/>
-              </a:defRPr>
-            </a:pPr>
-            <a:r>
-              <a:t>LGPD, protocolos e integrações</a:t>
+            <a:r>
+              <a:t>TTL, Storage lifecycle, App Check e protocolos</a:t>
             </a:r>
           </a:p>
         </p:txBody>
@@ -7644,19 +7592,8 @@
           </a:bodyPr>
           <a:lstStyle xmlns:a="http://schemas.openxmlformats.org/drawingml/2006/main"/>
           <a:p xmlns:a="http://schemas.openxmlformats.org/drawingml/2006/main">
-            <a:pPr algn="ctr">
-              <a:buNone/>
-              <a:defRPr sz="1600" b="1">
-                <a:solidFill>
-                  <a:srgbClr val="17233A"/>
-                </a:solidFill>
-                <a:latin typeface="Aptos"/>
-                <a:ea typeface="Aptos"/>
-                <a:cs typeface="Aptos"/>
-              </a:defRPr>
-            </a:pPr>
-            <a:r>
-              <a:t>Operação institucional</a:t>
+            <a:r>
+              <a:t>Piloto institucional</a:t>
             </a:r>
           </a:p>
         </p:txBody>
@@ -7691,19 +7628,8 @@
           </a:bodyPr>
           <a:lstStyle xmlns:a="http://schemas.openxmlformats.org/drawingml/2006/main"/>
           <a:p xmlns:a="http://schemas.openxmlformats.org/drawingml/2006/main">
-            <a:pPr algn="ctr">
-              <a:buNone/>
-              <a:defRPr sz="1100" b="0">
-                <a:solidFill>
-                  <a:srgbClr val="60728A"/>
-                </a:solidFill>
-                <a:latin typeface="Aptos"/>
-                <a:ea typeface="Aptos"/>
-                <a:cs typeface="Aptos"/>
-              </a:defRPr>
-            </a:pPr>
-            <a:r>
-              <a:t>Monitoramento, SLAs e análise preventiva</a:t>
+            <a:r>
+              <a:t>Autorizações, SLAs, operação e análise preventiva</a:t>
             </a:r>
           </a:p>
         </p:txBody>
@@ -7738,19 +7664,8 @@
           </a:bodyPr>
           <a:lstStyle xmlns:a="http://schemas.openxmlformats.org/drawingml/2006/main"/>
           <a:p xmlns:a="http://schemas.openxmlformats.org/drawingml/2006/main">
-            <a:pPr algn="ctr">
-              <a:buNone/>
-              <a:defRPr sz="1500" b="1">
-                <a:solidFill>
-                  <a:srgbClr val="082F57"/>
-                </a:solidFill>
-                <a:latin typeface="Aptos"/>
-                <a:ea typeface="Aptos"/>
-                <a:cs typeface="Aptos"/>
-              </a:defRPr>
-            </a:pPr>
-            <a:r>
-              <a:t>Próxima validação: compreender a percepção de segurança da comunidade e ajustar a solução antes de uma implantação institucional.</a:t>
+            <a:r>
+              <a:t>Próxima validação: comprovar o fluxo ponta a ponta com contas de teste, documentar evidências e só então avançar para um piloto institucional.</a:t>
             </a:r>
           </a:p>
         </p:txBody>
@@ -8458,6 +8373,2690 @@
 </p:sld>
 </file>
 
+<file path=ppt/slides/slide13.xml><?xml version="1.0" encoding="utf-8"?>
+<p:sld xmlns:a="http://schemas.openxmlformats.org/drawingml/2006/main" xmlns:p="http://schemas.openxmlformats.org/presentationml/2006/main" xmlns:r="http://schemas.openxmlformats.org/officeDocument/2006/relationships">
+  <p:cSld>
+    <p:bg>
+      <p:bgPr>
+        <a:solidFill>
+          <a:srgbClr val="F4F8FB"/>
+        </a:solidFill>
+        <a:effectLst/>
+      </p:bgPr>
+    </p:bg>
+    <p:spTree>
+      <p:nvGrpSpPr>
+        <p:cNvPr id="1" name=""/>
+        <p:cNvGrpSpPr/>
+        <p:nvPr/>
+      </p:nvGrpSpPr>
+      <p:grpSpPr/>
+      <p:sp>
+        <p:nvSpPr>
+          <p:cNvPr id="2" name="Rectangle 1"/>
+          <p:cNvSpPr/>
+          <p:nvPr/>
+        </p:nvSpPr>
+        <p:spPr>
+          <a:xfrm>
+            <a:off x="548640" y="411480"/>
+            <a:ext cx="1280160" cy="36576"/>
+          </a:xfrm>
+          <a:prstGeom prst="rect">
+            <a:avLst/>
+          </a:prstGeom>
+          <a:solidFill>
+            <a:srgbClr val="12B5CB"/>
+          </a:solidFill>
+          <a:ln>
+            <a:noFill/>
+          </a:ln>
+        </p:spPr>
+        <p:style>
+          <a:lnRef idx="1">
+            <a:schemeClr val="accent1"/>
+          </a:lnRef>
+          <a:fillRef idx="3">
+            <a:schemeClr val="accent1"/>
+          </a:fillRef>
+          <a:effectRef idx="2">
+            <a:schemeClr val="accent1"/>
+          </a:effectRef>
+          <a:fontRef idx="minor">
+            <a:schemeClr val="lt1"/>
+          </a:fontRef>
+        </p:style>
+        <p:txBody>
+          <a:bodyPr rtlCol="0" anchor="ctr"/>
+          <a:lstStyle/>
+          <a:p>
+            <a:pPr algn="ctr"/>
+          </a:p>
+        </p:txBody>
+      </p:sp>
+      <p:sp>
+        <p:nvSpPr>
+          <p:cNvPr id="3" name="TextBox 2"/>
+          <p:cNvSpPr txBox="1"/>
+          <p:nvPr/>
+        </p:nvSpPr>
+        <p:spPr>
+          <a:xfrm>
+            <a:off x="548640" y="530352"/>
+            <a:ext cx="2560320" cy="228600"/>
+          </a:xfrm>
+          <a:prstGeom prst="rect">
+            <a:avLst/>
+          </a:prstGeom>
+          <a:noFill/>
+        </p:spPr>
+        <p:txBody>
+          <a:bodyPr wrap="square">
+            <a:spAutoFit/>
+          </a:bodyPr>
+          <a:lstStyle/>
+          <a:p>
+            <a:pPr algn="l"/>
+            <a:r>
+              <a:rPr sz="1000" b="1">
+                <a:solidFill>
+                  <a:srgbClr val="12B5CB"/>
+                </a:solidFill>
+                <a:latin typeface="Aptos"/>
+              </a:rPr>
+              <a:t>REQUISITOS</a:t>
+            </a:r>
+          </a:p>
+        </p:txBody>
+      </p:sp>
+      <p:sp>
+        <p:nvSpPr>
+          <p:cNvPr id="4" name="TextBox 3"/>
+          <p:cNvSpPr txBox="1"/>
+          <p:nvPr/>
+        </p:nvSpPr>
+        <p:spPr>
+          <a:xfrm>
+            <a:off x="548640" y="868680"/>
+            <a:ext cx="10332720" cy="548640"/>
+          </a:xfrm>
+          <a:prstGeom prst="rect">
+            <a:avLst/>
+          </a:prstGeom>
+          <a:noFill/>
+        </p:spPr>
+        <p:txBody>
+          <a:bodyPr wrap="square">
+            <a:spAutoFit/>
+          </a:bodyPr>
+          <a:lstStyle/>
+          <a:p>
+            <a:pPr algn="l"/>
+            <a:r>
+              <a:rPr sz="2700" b="1">
+                <a:solidFill>
+                  <a:srgbClr val="0B2E4D"/>
+                </a:solidFill>
+                <a:latin typeface="Aptos"/>
+              </a:rPr>
+              <a:t>Requisitos funcionais aplicados</a:t>
+            </a:r>
+          </a:p>
+        </p:txBody>
+      </p:sp>
+      <p:sp>
+        <p:nvSpPr>
+          <p:cNvPr id="5" name="Rounded Rectangle 4"/>
+          <p:cNvSpPr/>
+          <p:nvPr/>
+        </p:nvSpPr>
+        <p:spPr>
+          <a:xfrm>
+            <a:off x="548640" y="1645920"/>
+            <a:ext cx="4892040" cy="4251960"/>
+          </a:xfrm>
+          <a:prstGeom prst="roundRect">
+            <a:avLst/>
+          </a:prstGeom>
+          <a:solidFill>
+            <a:srgbClr val="FFFFFF"/>
+          </a:solidFill>
+          <a:ln>
+            <a:solidFill>
+              <a:srgbClr val="DEE5EB"/>
+            </a:solidFill>
+          </a:ln>
+        </p:spPr>
+        <p:style>
+          <a:lnRef idx="1">
+            <a:schemeClr val="accent1"/>
+          </a:lnRef>
+          <a:fillRef idx="3">
+            <a:schemeClr val="accent1"/>
+          </a:fillRef>
+          <a:effectRef idx="2">
+            <a:schemeClr val="accent1"/>
+          </a:effectRef>
+          <a:fontRef idx="minor">
+            <a:schemeClr val="lt1"/>
+          </a:fontRef>
+        </p:style>
+        <p:txBody>
+          <a:bodyPr rtlCol="0" anchor="ctr"/>
+          <a:lstStyle/>
+          <a:p>
+            <a:pPr algn="ctr"/>
+          </a:p>
+        </p:txBody>
+      </p:sp>
+      <p:sp>
+        <p:nvSpPr>
+          <p:cNvPr id="6" name="Rectangle 5"/>
+          <p:cNvSpPr/>
+          <p:nvPr/>
+        </p:nvSpPr>
+        <p:spPr>
+          <a:xfrm>
+            <a:off x="548640" y="1645920"/>
+            <a:ext cx="4892040" cy="64008"/>
+          </a:xfrm>
+          <a:prstGeom prst="rect">
+            <a:avLst/>
+          </a:prstGeom>
+          <a:solidFill>
+            <a:srgbClr val="0078B5"/>
+          </a:solidFill>
+          <a:ln>
+            <a:noFill/>
+          </a:ln>
+        </p:spPr>
+        <p:style>
+          <a:lnRef idx="1">
+            <a:schemeClr val="accent1"/>
+          </a:lnRef>
+          <a:fillRef idx="3">
+            <a:schemeClr val="accent1"/>
+          </a:fillRef>
+          <a:effectRef idx="2">
+            <a:schemeClr val="accent1"/>
+          </a:effectRef>
+          <a:fontRef idx="minor">
+            <a:schemeClr val="lt1"/>
+          </a:fontRef>
+        </p:style>
+        <p:txBody>
+          <a:bodyPr rtlCol="0" anchor="ctr"/>
+          <a:lstStyle/>
+          <a:p>
+            <a:pPr algn="ctr"/>
+          </a:p>
+        </p:txBody>
+      </p:sp>
+      <p:sp>
+        <p:nvSpPr>
+          <p:cNvPr id="7" name="TextBox 6"/>
+          <p:cNvSpPr txBox="1"/>
+          <p:nvPr/>
+        </p:nvSpPr>
+        <p:spPr>
+          <a:xfrm>
+            <a:off x="777240" y="1874519"/>
+            <a:ext cx="4434840" cy="320040"/>
+          </a:xfrm>
+          <a:prstGeom prst="rect">
+            <a:avLst/>
+          </a:prstGeom>
+          <a:noFill/>
+        </p:spPr>
+        <p:txBody>
+          <a:bodyPr wrap="square">
+            <a:spAutoFit/>
+          </a:bodyPr>
+          <a:lstStyle/>
+          <a:p>
+            <a:pPr algn="l"/>
+            <a:r>
+              <a:rPr sz="1500" b="1">
+                <a:solidFill>
+                  <a:srgbClr val="0B2E4D"/>
+                </a:solidFill>
+                <a:latin typeface="Aptos"/>
+              </a:rPr>
+              <a:t>RF01–RF06</a:t>
+            </a:r>
+          </a:p>
+        </p:txBody>
+      </p:sp>
+      <p:sp>
+        <p:nvSpPr>
+          <p:cNvPr id="8" name="TextBox 7"/>
+          <p:cNvSpPr txBox="1"/>
+          <p:nvPr/>
+        </p:nvSpPr>
+        <p:spPr>
+          <a:xfrm>
+            <a:off x="804672" y="2331720"/>
+            <a:ext cx="4370832" cy="484632"/>
+          </a:xfrm>
+          <a:prstGeom prst="rect">
+            <a:avLst/>
+          </a:prstGeom>
+          <a:noFill/>
+        </p:spPr>
+        <p:txBody>
+          <a:bodyPr wrap="square">
+            <a:spAutoFit/>
+          </a:bodyPr>
+          <a:lstStyle/>
+          <a:p>
+            <a:pPr algn="l"/>
+            <a:r>
+              <a:rPr sz="1100" b="0">
+                <a:solidFill>
+                  <a:srgbClr val="222831"/>
+                </a:solidFill>
+                <a:latin typeface="Aptos"/>
+              </a:rPr>
+              <a:t>• RF01 – Cadastrar e autenticar por e-mail e senha.</a:t>
+            </a:r>
+          </a:p>
+        </p:txBody>
+      </p:sp>
+      <p:sp>
+        <p:nvSpPr>
+          <p:cNvPr id="9" name="TextBox 8"/>
+          <p:cNvSpPr txBox="1"/>
+          <p:nvPr/>
+        </p:nvSpPr>
+        <p:spPr>
+          <a:xfrm>
+            <a:off x="804672" y="2862072"/>
+            <a:ext cx="4370832" cy="484632"/>
+          </a:xfrm>
+          <a:prstGeom prst="rect">
+            <a:avLst/>
+          </a:prstGeom>
+          <a:noFill/>
+        </p:spPr>
+        <p:txBody>
+          <a:bodyPr wrap="square">
+            <a:spAutoFit/>
+          </a:bodyPr>
+          <a:lstStyle/>
+          <a:p>
+            <a:pPr algn="l"/>
+            <a:r>
+              <a:rPr sz="1100" b="0">
+                <a:solidFill>
+                  <a:srgbClr val="222831"/>
+                </a:solidFill>
+                <a:latin typeface="Aptos"/>
+              </a:rPr>
+              <a:t>• RF02 – Exigir e-mail verificado e vínculo institucional ativo.</a:t>
+            </a:r>
+          </a:p>
+        </p:txBody>
+      </p:sp>
+      <p:sp>
+        <p:nvSpPr>
+          <p:cNvPr id="10" name="TextBox 9"/>
+          <p:cNvSpPr txBox="1"/>
+          <p:nvPr/>
+        </p:nvSpPr>
+        <p:spPr>
+          <a:xfrm>
+            <a:off x="804672" y="3392424"/>
+            <a:ext cx="4370832" cy="484632"/>
+          </a:xfrm>
+          <a:prstGeom prst="rect">
+            <a:avLst/>
+          </a:prstGeom>
+          <a:noFill/>
+        </p:spPr>
+        <p:txBody>
+          <a:bodyPr wrap="square">
+            <a:spAutoFit/>
+          </a:bodyPr>
+          <a:lstStyle/>
+          <a:p>
+            <a:pPr algn="l"/>
+            <a:r>
+              <a:rPr sz="1100" b="0">
+                <a:solidFill>
+                  <a:srgbClr val="222831"/>
+                </a:solidFill>
+                <a:latin typeface="Aptos"/>
+              </a:rPr>
+              <a:t>• RF03 – Associar usuário à instituição/campus autorizado.</a:t>
+            </a:r>
+          </a:p>
+        </p:txBody>
+      </p:sp>
+      <p:sp>
+        <p:nvSpPr>
+          <p:cNvPr id="11" name="TextBox 10"/>
+          <p:cNvSpPr txBox="1"/>
+          <p:nvPr/>
+        </p:nvSpPr>
+        <p:spPr>
+          <a:xfrm>
+            <a:off x="804672" y="3922776"/>
+            <a:ext cx="4370832" cy="484632"/>
+          </a:xfrm>
+          <a:prstGeom prst="rect">
+            <a:avLst/>
+          </a:prstGeom>
+          <a:noFill/>
+        </p:spPr>
+        <p:txBody>
+          <a:bodyPr wrap="square">
+            <a:spAutoFit/>
+          </a:bodyPr>
+          <a:lstStyle/>
+          <a:p>
+            <a:pPr algn="l"/>
+            <a:r>
+              <a:rPr sz="1100" b="0">
+                <a:solidFill>
+                  <a:srgbClr val="222831"/>
+                </a:solidFill>
+                <a:latin typeface="Aptos"/>
+              </a:rPr>
+              <a:t>• RF04 – Obter localização mediante permissão.</a:t>
+            </a:r>
+          </a:p>
+        </p:txBody>
+      </p:sp>
+      <p:sp>
+        <p:nvSpPr>
+          <p:cNvPr id="12" name="TextBox 11"/>
+          <p:cNvSpPr txBox="1"/>
+          <p:nvPr/>
+        </p:nvSpPr>
+        <p:spPr>
+          <a:xfrm>
+            <a:off x="804672" y="4453128"/>
+            <a:ext cx="4370832" cy="484632"/>
+          </a:xfrm>
+          <a:prstGeom prst="rect">
+            <a:avLst/>
+          </a:prstGeom>
+          <a:noFill/>
+        </p:spPr>
+        <p:txBody>
+          <a:bodyPr wrap="square">
+            <a:spAutoFit/>
+          </a:bodyPr>
+          <a:lstStyle/>
+          <a:p>
+            <a:pPr algn="l"/>
+            <a:r>
+              <a:rPr sz="1100" b="0">
+                <a:solidFill>
+                  <a:srgbClr val="222831"/>
+                </a:solidFill>
+                <a:latin typeface="Aptos"/>
+              </a:rPr>
+              <a:t>• RF05 – Criar SOS com categoria, data/hora e localização.</a:t>
+            </a:r>
+          </a:p>
+        </p:txBody>
+      </p:sp>
+      <p:sp>
+        <p:nvSpPr>
+          <p:cNvPr id="13" name="TextBox 12"/>
+          <p:cNvSpPr txBox="1"/>
+          <p:nvPr/>
+        </p:nvSpPr>
+        <p:spPr>
+          <a:xfrm>
+            <a:off x="804672" y="4983480"/>
+            <a:ext cx="4370832" cy="484632"/>
+          </a:xfrm>
+          <a:prstGeom prst="rect">
+            <a:avLst/>
+          </a:prstGeom>
+          <a:noFill/>
+        </p:spPr>
+        <p:txBody>
+          <a:bodyPr wrap="square">
+            <a:spAutoFit/>
+          </a:bodyPr>
+          <a:lstStyle/>
+          <a:p>
+            <a:pPr algn="l"/>
+            <a:r>
+              <a:rPr sz="1100" b="0">
+                <a:solidFill>
+                  <a:srgbClr val="222831"/>
+                </a:solidFill>
+                <a:latin typeface="Aptos"/>
+              </a:rPr>
+              <a:t>• RF06 – Anexar evidência fotográfica quando autorizada.</a:t>
+            </a:r>
+          </a:p>
+        </p:txBody>
+      </p:sp>
+      <p:sp>
+        <p:nvSpPr>
+          <p:cNvPr id="14" name="Rounded Rectangle 13"/>
+          <p:cNvSpPr/>
+          <p:nvPr/>
+        </p:nvSpPr>
+        <p:spPr>
+          <a:xfrm>
+            <a:off x="5989320" y="1645920"/>
+            <a:ext cx="4892040" cy="4251960"/>
+          </a:xfrm>
+          <a:prstGeom prst="roundRect">
+            <a:avLst/>
+          </a:prstGeom>
+          <a:solidFill>
+            <a:srgbClr val="FFFFFF"/>
+          </a:solidFill>
+          <a:ln>
+            <a:solidFill>
+              <a:srgbClr val="DEE5EB"/>
+            </a:solidFill>
+          </a:ln>
+        </p:spPr>
+        <p:style>
+          <a:lnRef idx="1">
+            <a:schemeClr val="accent1"/>
+          </a:lnRef>
+          <a:fillRef idx="3">
+            <a:schemeClr val="accent1"/>
+          </a:fillRef>
+          <a:effectRef idx="2">
+            <a:schemeClr val="accent1"/>
+          </a:effectRef>
+          <a:fontRef idx="minor">
+            <a:schemeClr val="lt1"/>
+          </a:fontRef>
+        </p:style>
+        <p:txBody>
+          <a:bodyPr rtlCol="0" anchor="ctr"/>
+          <a:lstStyle/>
+          <a:p>
+            <a:pPr algn="ctr"/>
+          </a:p>
+        </p:txBody>
+      </p:sp>
+      <p:sp>
+        <p:nvSpPr>
+          <p:cNvPr id="15" name="Rectangle 14"/>
+          <p:cNvSpPr/>
+          <p:nvPr/>
+        </p:nvSpPr>
+        <p:spPr>
+          <a:xfrm>
+            <a:off x="5989320" y="1645920"/>
+            <a:ext cx="4892040" cy="64008"/>
+          </a:xfrm>
+          <a:prstGeom prst="rect">
+            <a:avLst/>
+          </a:prstGeom>
+          <a:solidFill>
+            <a:srgbClr val="109E78"/>
+          </a:solidFill>
+          <a:ln>
+            <a:noFill/>
+          </a:ln>
+        </p:spPr>
+        <p:style>
+          <a:lnRef idx="1">
+            <a:schemeClr val="accent1"/>
+          </a:lnRef>
+          <a:fillRef idx="3">
+            <a:schemeClr val="accent1"/>
+          </a:fillRef>
+          <a:effectRef idx="2">
+            <a:schemeClr val="accent1"/>
+          </a:effectRef>
+          <a:fontRef idx="minor">
+            <a:schemeClr val="lt1"/>
+          </a:fontRef>
+        </p:style>
+        <p:txBody>
+          <a:bodyPr rtlCol="0" anchor="ctr"/>
+          <a:lstStyle/>
+          <a:p>
+            <a:pPr algn="ctr"/>
+          </a:p>
+        </p:txBody>
+      </p:sp>
+      <p:sp>
+        <p:nvSpPr>
+          <p:cNvPr id="16" name="TextBox 15"/>
+          <p:cNvSpPr txBox="1"/>
+          <p:nvPr/>
+        </p:nvSpPr>
+        <p:spPr>
+          <a:xfrm>
+            <a:off x="6217920" y="1874519"/>
+            <a:ext cx="4434840" cy="320040"/>
+          </a:xfrm>
+          <a:prstGeom prst="rect">
+            <a:avLst/>
+          </a:prstGeom>
+          <a:noFill/>
+        </p:spPr>
+        <p:txBody>
+          <a:bodyPr wrap="square">
+            <a:spAutoFit/>
+          </a:bodyPr>
+          <a:lstStyle/>
+          <a:p>
+            <a:pPr algn="l"/>
+            <a:r>
+              <a:rPr sz="1500" b="1">
+                <a:solidFill>
+                  <a:srgbClr val="0B2E4D"/>
+                </a:solidFill>
+                <a:latin typeface="Aptos"/>
+              </a:rPr>
+              <a:t>RF07–RF12</a:t>
+            </a:r>
+          </a:p>
+        </p:txBody>
+      </p:sp>
+      <p:sp>
+        <p:nvSpPr>
+          <p:cNvPr id="17" name="TextBox 16"/>
+          <p:cNvSpPr txBox="1"/>
+          <p:nvPr/>
+        </p:nvSpPr>
+        <p:spPr>
+          <a:xfrm>
+            <a:off x="6245352" y="2331720"/>
+            <a:ext cx="4370832" cy="484632"/>
+          </a:xfrm>
+          <a:prstGeom prst="rect">
+            <a:avLst/>
+          </a:prstGeom>
+          <a:noFill/>
+        </p:spPr>
+        <p:txBody>
+          <a:bodyPr wrap="square">
+            <a:spAutoFit/>
+          </a:bodyPr>
+          <a:lstStyle/>
+          <a:p>
+            <a:pPr algn="l"/>
+            <a:r>
+              <a:rPr sz="1100" b="0">
+                <a:solidFill>
+                  <a:srgbClr val="222831"/>
+                </a:solidFill>
+                <a:latin typeface="Aptos"/>
+              </a:rPr>
+              <a:t>• RF07 – Exibir alertas ao operador da mesma instituição.</a:t>
+            </a:r>
+          </a:p>
+        </p:txBody>
+      </p:sp>
+      <p:sp>
+        <p:nvSpPr>
+          <p:cNvPr id="18" name="TextBox 17"/>
+          <p:cNvSpPr txBox="1"/>
+          <p:nvPr/>
+        </p:nvSpPr>
+        <p:spPr>
+          <a:xfrm>
+            <a:off x="6245352" y="2862072"/>
+            <a:ext cx="4370832" cy="484632"/>
+          </a:xfrm>
+          <a:prstGeom prst="rect">
+            <a:avLst/>
+          </a:prstGeom>
+          <a:noFill/>
+        </p:spPr>
+        <p:txBody>
+          <a:bodyPr wrap="square">
+            <a:spAutoFit/>
+          </a:bodyPr>
+          <a:lstStyle/>
+          <a:p>
+            <a:pPr algn="l"/>
+            <a:r>
+              <a:rPr sz="1100" b="0">
+                <a:solidFill>
+                  <a:srgbClr val="222831"/>
+                </a:solidFill>
+                <a:latin typeface="Aptos"/>
+              </a:rPr>
+              <a:t>• RF08 – Registrar recebimento, visualização e mudanças de status.</a:t>
+            </a:r>
+          </a:p>
+        </p:txBody>
+      </p:sp>
+      <p:sp>
+        <p:nvSpPr>
+          <p:cNvPr id="19" name="TextBox 18"/>
+          <p:cNvSpPr txBox="1"/>
+          <p:nvPr/>
+        </p:nvSpPr>
+        <p:spPr>
+          <a:xfrm>
+            <a:off x="6245352" y="3392424"/>
+            <a:ext cx="4370832" cy="484632"/>
+          </a:xfrm>
+          <a:prstGeom prst="rect">
+            <a:avLst/>
+          </a:prstGeom>
+          <a:noFill/>
+        </p:spPr>
+        <p:txBody>
+          <a:bodyPr wrap="square">
+            <a:spAutoFit/>
+          </a:bodyPr>
+          <a:lstStyle/>
+          <a:p>
+            <a:pPr algn="l"/>
+            <a:r>
+              <a:rPr sz="1100" b="0">
+                <a:solidFill>
+                  <a:srgbClr val="222831"/>
+                </a:solidFill>
+                <a:latin typeface="Aptos"/>
+              </a:rPr>
+              <a:t>• RF09 – Permitir acompanhamento e histórico do alerta.</a:t>
+            </a:r>
+          </a:p>
+        </p:txBody>
+      </p:sp>
+      <p:sp>
+        <p:nvSpPr>
+          <p:cNvPr id="20" name="TextBox 19"/>
+          <p:cNvSpPr txBox="1"/>
+          <p:nvPr/>
+        </p:nvSpPr>
+        <p:spPr>
+          <a:xfrm>
+            <a:off x="6245352" y="3922776"/>
+            <a:ext cx="4370832" cy="484632"/>
+          </a:xfrm>
+          <a:prstGeom prst="rect">
+            <a:avLst/>
+          </a:prstGeom>
+          <a:noFill/>
+        </p:spPr>
+        <p:txBody>
+          <a:bodyPr wrap="square">
+            <a:spAutoFit/>
+          </a:bodyPr>
+          <a:lstStyle/>
+          <a:p>
+            <a:pPr algn="l"/>
+            <a:r>
+              <a:rPr sz="1100" b="0">
+                <a:solidFill>
+                  <a:srgbClr val="222831"/>
+                </a:solidFill>
+                <a:latin typeface="Aptos"/>
+              </a:rPr>
+              <a:t>• RF10 – Registrar eventos de auditoria.</a:t>
+            </a:r>
+          </a:p>
+        </p:txBody>
+      </p:sp>
+      <p:sp>
+        <p:nvSpPr>
+          <p:cNvPr id="21" name="TextBox 20"/>
+          <p:cNvSpPr txBox="1"/>
+          <p:nvPr/>
+        </p:nvSpPr>
+        <p:spPr>
+          <a:xfrm>
+            <a:off x="6245352" y="4453128"/>
+            <a:ext cx="4370832" cy="484632"/>
+          </a:xfrm>
+          <a:prstGeom prst="rect">
+            <a:avLst/>
+          </a:prstGeom>
+          <a:noFill/>
+        </p:spPr>
+        <p:txBody>
+          <a:bodyPr wrap="square">
+            <a:spAutoFit/>
+          </a:bodyPr>
+          <a:lstStyle/>
+          <a:p>
+            <a:pPr algn="l"/>
+            <a:r>
+              <a:rPr sz="1100" b="0">
+                <a:solidFill>
+                  <a:srgbClr val="222831"/>
+                </a:solidFill>
+                <a:latin typeface="Aptos"/>
+              </a:rPr>
+              <a:t>• RF11 – Bloquear criação abusiva/repetitiva de alertas.</a:t>
+            </a:r>
+          </a:p>
+        </p:txBody>
+      </p:sp>
+      <p:sp>
+        <p:nvSpPr>
+          <p:cNvPr id="22" name="TextBox 21"/>
+          <p:cNvSpPr txBox="1"/>
+          <p:nvPr/>
+        </p:nvSpPr>
+        <p:spPr>
+          <a:xfrm>
+            <a:off x="6245352" y="4983480"/>
+            <a:ext cx="4370832" cy="484632"/>
+          </a:xfrm>
+          <a:prstGeom prst="rect">
+            <a:avLst/>
+          </a:prstGeom>
+          <a:noFill/>
+        </p:spPr>
+        <p:txBody>
+          <a:bodyPr wrap="square">
+            <a:spAutoFit/>
+          </a:bodyPr>
+          <a:lstStyle/>
+          <a:p>
+            <a:pPr algn="l"/>
+            <a:r>
+              <a:rPr sz="1100" b="0">
+                <a:solidFill>
+                  <a:srgbClr val="222831"/>
+                </a:solidFill>
+                <a:latin typeface="Aptos"/>
+              </a:rPr>
+              <a:t>• RF12 – Limpar dados temporários locais conforme retenção.</a:t>
+            </a:r>
+          </a:p>
+        </p:txBody>
+      </p:sp>
+      <p:sp>
+        <p:nvSpPr>
+          <p:cNvPr id="23" name="Rectangle 22"/>
+          <p:cNvSpPr/>
+          <p:nvPr/>
+        </p:nvSpPr>
+        <p:spPr>
+          <a:xfrm>
+            <a:off x="548640" y="6446520"/>
+            <a:ext cx="10287000" cy="10972"/>
+          </a:xfrm>
+          <a:prstGeom prst="rect">
+            <a:avLst/>
+          </a:prstGeom>
+          <a:solidFill>
+            <a:srgbClr val="DCE2E8"/>
+          </a:solidFill>
+          <a:ln>
+            <a:noFill/>
+          </a:ln>
+        </p:spPr>
+        <p:style>
+          <a:lnRef idx="1">
+            <a:schemeClr val="accent1"/>
+          </a:lnRef>
+          <a:fillRef idx="3">
+            <a:schemeClr val="accent1"/>
+          </a:fillRef>
+          <a:effectRef idx="2">
+            <a:schemeClr val="accent1"/>
+          </a:effectRef>
+          <a:fontRef idx="minor">
+            <a:schemeClr val="lt1"/>
+          </a:fontRef>
+        </p:style>
+        <p:txBody>
+          <a:bodyPr rtlCol="0" anchor="ctr"/>
+          <a:lstStyle/>
+          <a:p>
+            <a:pPr algn="ctr"/>
+          </a:p>
+        </p:txBody>
+      </p:sp>
+      <p:sp>
+        <p:nvSpPr>
+          <p:cNvPr id="24" name="TextBox 23"/>
+          <p:cNvSpPr txBox="1"/>
+          <p:nvPr/>
+        </p:nvSpPr>
+        <p:spPr>
+          <a:xfrm>
+            <a:off x="548640" y="6510528"/>
+            <a:ext cx="5029200" cy="182880"/>
+          </a:xfrm>
+          <a:prstGeom prst="rect">
+            <a:avLst/>
+          </a:prstGeom>
+          <a:noFill/>
+        </p:spPr>
+        <p:txBody>
+          <a:bodyPr wrap="square">
+            <a:spAutoFit/>
+          </a:bodyPr>
+          <a:lstStyle/>
+          <a:p>
+            <a:pPr algn="l"/>
+            <a:r>
+              <a:rPr sz="800" b="0">
+                <a:solidFill>
+                  <a:srgbClr val="646E78"/>
+                </a:solidFill>
+                <a:latin typeface="Aptos"/>
+              </a:rPr>
+              <a:t>PROTÓTIPO ACADÊMICO • DADOS DEMONSTRATIVOS</a:t>
+            </a:r>
+          </a:p>
+        </p:txBody>
+      </p:sp>
+      <p:sp>
+        <p:nvSpPr>
+          <p:cNvPr id="25" name="TextBox 24"/>
+          <p:cNvSpPr txBox="1"/>
+          <p:nvPr/>
+        </p:nvSpPr>
+        <p:spPr>
+          <a:xfrm>
+            <a:off x="10442448" y="6473952"/>
+            <a:ext cx="365760" cy="228600"/>
+          </a:xfrm>
+          <a:prstGeom prst="rect">
+            <a:avLst/>
+          </a:prstGeom>
+          <a:noFill/>
+        </p:spPr>
+        <p:txBody>
+          <a:bodyPr wrap="square">
+            <a:spAutoFit/>
+          </a:bodyPr>
+          <a:lstStyle/>
+          <a:p>
+            <a:pPr algn="r"/>
+            <a:r>
+              <a:rPr sz="800" b="0">
+                <a:solidFill>
+                  <a:srgbClr val="646E78"/>
+                </a:solidFill>
+                <a:latin typeface="Aptos"/>
+              </a:rPr>
+              <a:t>13</a:t>
+            </a:r>
+          </a:p>
+        </p:txBody>
+      </p:sp>
+    </p:spTree>
+  </p:cSld>
+  <p:clrMapOvr>
+    <a:masterClrMapping/>
+  </p:clrMapOvr>
+</p:sld>
+</file>
+
+<file path=ppt/slides/slide14.xml><?xml version="1.0" encoding="utf-8"?>
+<p:sld xmlns:a="http://schemas.openxmlformats.org/drawingml/2006/main" xmlns:p="http://schemas.openxmlformats.org/presentationml/2006/main" xmlns:r="http://schemas.openxmlformats.org/officeDocument/2006/relationships">
+  <p:cSld>
+    <p:bg>
+      <p:bgPr>
+        <a:solidFill>
+          <a:srgbClr val="F4F8FB"/>
+        </a:solidFill>
+        <a:effectLst/>
+      </p:bgPr>
+    </p:bg>
+    <p:spTree>
+      <p:nvGrpSpPr>
+        <p:cNvPr id="1" name=""/>
+        <p:cNvGrpSpPr/>
+        <p:nvPr/>
+      </p:nvGrpSpPr>
+      <p:grpSpPr/>
+      <p:sp>
+        <p:nvSpPr>
+          <p:cNvPr id="2" name="Rectangle 1"/>
+          <p:cNvSpPr/>
+          <p:nvPr/>
+        </p:nvSpPr>
+        <p:spPr>
+          <a:xfrm>
+            <a:off x="548640" y="411480"/>
+            <a:ext cx="1280160" cy="36576"/>
+          </a:xfrm>
+          <a:prstGeom prst="rect">
+            <a:avLst/>
+          </a:prstGeom>
+          <a:solidFill>
+            <a:srgbClr val="12B5CB"/>
+          </a:solidFill>
+          <a:ln>
+            <a:noFill/>
+          </a:ln>
+        </p:spPr>
+        <p:style>
+          <a:lnRef idx="1">
+            <a:schemeClr val="accent1"/>
+          </a:lnRef>
+          <a:fillRef idx="3">
+            <a:schemeClr val="accent1"/>
+          </a:fillRef>
+          <a:effectRef idx="2">
+            <a:schemeClr val="accent1"/>
+          </a:effectRef>
+          <a:fontRef idx="minor">
+            <a:schemeClr val="lt1"/>
+          </a:fontRef>
+        </p:style>
+        <p:txBody>
+          <a:bodyPr rtlCol="0" anchor="ctr"/>
+          <a:lstStyle/>
+          <a:p>
+            <a:pPr algn="ctr"/>
+          </a:p>
+        </p:txBody>
+      </p:sp>
+      <p:sp>
+        <p:nvSpPr>
+          <p:cNvPr id="3" name="TextBox 2"/>
+          <p:cNvSpPr txBox="1"/>
+          <p:nvPr/>
+        </p:nvSpPr>
+        <p:spPr>
+          <a:xfrm>
+            <a:off x="548640" y="530352"/>
+            <a:ext cx="2560320" cy="228600"/>
+          </a:xfrm>
+          <a:prstGeom prst="rect">
+            <a:avLst/>
+          </a:prstGeom>
+          <a:noFill/>
+        </p:spPr>
+        <p:txBody>
+          <a:bodyPr wrap="square">
+            <a:spAutoFit/>
+          </a:bodyPr>
+          <a:lstStyle/>
+          <a:p>
+            <a:pPr algn="l"/>
+            <a:r>
+              <a:rPr sz="1000" b="1">
+                <a:solidFill>
+                  <a:srgbClr val="12B5CB"/>
+                </a:solidFill>
+                <a:latin typeface="Aptos"/>
+              </a:rPr>
+              <a:t>REQUISITOS</a:t>
+            </a:r>
+          </a:p>
+        </p:txBody>
+      </p:sp>
+      <p:sp>
+        <p:nvSpPr>
+          <p:cNvPr id="4" name="TextBox 3"/>
+          <p:cNvSpPr txBox="1"/>
+          <p:nvPr/>
+        </p:nvSpPr>
+        <p:spPr>
+          <a:xfrm>
+            <a:off x="548640" y="868680"/>
+            <a:ext cx="10332720" cy="548640"/>
+          </a:xfrm>
+          <a:prstGeom prst="rect">
+            <a:avLst/>
+          </a:prstGeom>
+          <a:noFill/>
+        </p:spPr>
+        <p:txBody>
+          <a:bodyPr wrap="square">
+            <a:spAutoFit/>
+          </a:bodyPr>
+          <a:lstStyle/>
+          <a:p>
+            <a:pPr algn="l"/>
+            <a:r>
+              <a:rPr sz="2700" b="1">
+                <a:solidFill>
+                  <a:srgbClr val="0B2E4D"/>
+                </a:solidFill>
+                <a:latin typeface="Aptos"/>
+              </a:rPr>
+              <a:t>Requisitos não funcionais aplicados</a:t>
+            </a:r>
+          </a:p>
+        </p:txBody>
+      </p:sp>
+      <p:sp>
+        <p:nvSpPr>
+          <p:cNvPr id="5" name="Rounded Rectangle 4"/>
+          <p:cNvSpPr/>
+          <p:nvPr/>
+        </p:nvSpPr>
+        <p:spPr>
+          <a:xfrm>
+            <a:off x="548640" y="1645920"/>
+            <a:ext cx="4892040" cy="4251960"/>
+          </a:xfrm>
+          <a:prstGeom prst="roundRect">
+            <a:avLst/>
+          </a:prstGeom>
+          <a:solidFill>
+            <a:srgbClr val="FFFFFF"/>
+          </a:solidFill>
+          <a:ln>
+            <a:solidFill>
+              <a:srgbClr val="DEE5EB"/>
+            </a:solidFill>
+          </a:ln>
+        </p:spPr>
+        <p:style>
+          <a:lnRef idx="1">
+            <a:schemeClr val="accent1"/>
+          </a:lnRef>
+          <a:fillRef idx="3">
+            <a:schemeClr val="accent1"/>
+          </a:fillRef>
+          <a:effectRef idx="2">
+            <a:schemeClr val="accent1"/>
+          </a:effectRef>
+          <a:fontRef idx="minor">
+            <a:schemeClr val="lt1"/>
+          </a:fontRef>
+        </p:style>
+        <p:txBody>
+          <a:bodyPr rtlCol="0" anchor="ctr"/>
+          <a:lstStyle/>
+          <a:p>
+            <a:pPr algn="ctr"/>
+          </a:p>
+        </p:txBody>
+      </p:sp>
+      <p:sp>
+        <p:nvSpPr>
+          <p:cNvPr id="6" name="Rectangle 5"/>
+          <p:cNvSpPr/>
+          <p:nvPr/>
+        </p:nvSpPr>
+        <p:spPr>
+          <a:xfrm>
+            <a:off x="548640" y="1645920"/>
+            <a:ext cx="4892040" cy="64008"/>
+          </a:xfrm>
+          <a:prstGeom prst="rect">
+            <a:avLst/>
+          </a:prstGeom>
+          <a:solidFill>
+            <a:srgbClr val="0078B5"/>
+          </a:solidFill>
+          <a:ln>
+            <a:noFill/>
+          </a:ln>
+        </p:spPr>
+        <p:style>
+          <a:lnRef idx="1">
+            <a:schemeClr val="accent1"/>
+          </a:lnRef>
+          <a:fillRef idx="3">
+            <a:schemeClr val="accent1"/>
+          </a:fillRef>
+          <a:effectRef idx="2">
+            <a:schemeClr val="accent1"/>
+          </a:effectRef>
+          <a:fontRef idx="minor">
+            <a:schemeClr val="lt1"/>
+          </a:fontRef>
+        </p:style>
+        <p:txBody>
+          <a:bodyPr rtlCol="0" anchor="ctr"/>
+          <a:lstStyle/>
+          <a:p>
+            <a:pPr algn="ctr"/>
+          </a:p>
+        </p:txBody>
+      </p:sp>
+      <p:sp>
+        <p:nvSpPr>
+          <p:cNvPr id="7" name="TextBox 6"/>
+          <p:cNvSpPr txBox="1"/>
+          <p:nvPr/>
+        </p:nvSpPr>
+        <p:spPr>
+          <a:xfrm>
+            <a:off x="777240" y="1874519"/>
+            <a:ext cx="4434840" cy="320040"/>
+          </a:xfrm>
+          <a:prstGeom prst="rect">
+            <a:avLst/>
+          </a:prstGeom>
+          <a:noFill/>
+        </p:spPr>
+        <p:txBody>
+          <a:bodyPr wrap="square">
+            <a:spAutoFit/>
+          </a:bodyPr>
+          <a:lstStyle/>
+          <a:p>
+            <a:pPr algn="l"/>
+            <a:r>
+              <a:rPr sz="1500" b="1">
+                <a:solidFill>
+                  <a:srgbClr val="0B2E4D"/>
+                </a:solidFill>
+                <a:latin typeface="Aptos"/>
+              </a:rPr>
+              <a:t>RNF01–RNF05</a:t>
+            </a:r>
+          </a:p>
+        </p:txBody>
+      </p:sp>
+      <p:sp>
+        <p:nvSpPr>
+          <p:cNvPr id="8" name="TextBox 7"/>
+          <p:cNvSpPr txBox="1"/>
+          <p:nvPr/>
+        </p:nvSpPr>
+        <p:spPr>
+          <a:xfrm>
+            <a:off x="804672" y="2331720"/>
+            <a:ext cx="4370832" cy="484632"/>
+          </a:xfrm>
+          <a:prstGeom prst="rect">
+            <a:avLst/>
+          </a:prstGeom>
+          <a:noFill/>
+        </p:spPr>
+        <p:txBody>
+          <a:bodyPr wrap="square">
+            <a:spAutoFit/>
+          </a:bodyPr>
+          <a:lstStyle/>
+          <a:p>
+            <a:pPr algn="l"/>
+            <a:r>
+              <a:rPr sz="1100" b="0">
+                <a:solidFill>
+                  <a:srgbClr val="222831"/>
+                </a:solidFill>
+                <a:latin typeface="Aptos"/>
+              </a:rPr>
+              <a:t>• RNF01 – Acesso controlado por perfil, conta e instituição.</a:t>
+            </a:r>
+          </a:p>
+        </p:txBody>
+      </p:sp>
+      <p:sp>
+        <p:nvSpPr>
+          <p:cNvPr id="9" name="TextBox 8"/>
+          <p:cNvSpPr txBox="1"/>
+          <p:nvPr/>
+        </p:nvSpPr>
+        <p:spPr>
+          <a:xfrm>
+            <a:off x="804672" y="2862072"/>
+            <a:ext cx="4370832" cy="484632"/>
+          </a:xfrm>
+          <a:prstGeom prst="rect">
+            <a:avLst/>
+          </a:prstGeom>
+          <a:noFill/>
+        </p:spPr>
+        <p:txBody>
+          <a:bodyPr wrap="square">
+            <a:spAutoFit/>
+          </a:bodyPr>
+          <a:lstStyle/>
+          <a:p>
+            <a:pPr algn="l"/>
+            <a:r>
+              <a:rPr sz="1100" b="0">
+                <a:solidFill>
+                  <a:srgbClr val="222831"/>
+                </a:solidFill>
+                <a:latin typeface="Aptos"/>
+              </a:rPr>
+              <a:t>• RNF02 – Minimização de dados; sem prontuário médico.</a:t>
+            </a:r>
+          </a:p>
+        </p:txBody>
+      </p:sp>
+      <p:sp>
+        <p:nvSpPr>
+          <p:cNvPr id="10" name="TextBox 9"/>
+          <p:cNvSpPr txBox="1"/>
+          <p:nvPr/>
+        </p:nvSpPr>
+        <p:spPr>
+          <a:xfrm>
+            <a:off x="804672" y="3392424"/>
+            <a:ext cx="4370832" cy="484632"/>
+          </a:xfrm>
+          <a:prstGeom prst="rect">
+            <a:avLst/>
+          </a:prstGeom>
+          <a:noFill/>
+        </p:spPr>
+        <p:txBody>
+          <a:bodyPr wrap="square">
+            <a:spAutoFit/>
+          </a:bodyPr>
+          <a:lstStyle/>
+          <a:p>
+            <a:pPr algn="l"/>
+            <a:r>
+              <a:rPr sz="1100" b="0">
+                <a:solidFill>
+                  <a:srgbClr val="222831"/>
+                </a:solidFill>
+                <a:latin typeface="Aptos"/>
+              </a:rPr>
+              <a:t>• RNF03 – Auditoria append-only e rastreável.</a:t>
+            </a:r>
+          </a:p>
+        </p:txBody>
+      </p:sp>
+      <p:sp>
+        <p:nvSpPr>
+          <p:cNvPr id="11" name="TextBox 10"/>
+          <p:cNvSpPr txBox="1"/>
+          <p:nvPr/>
+        </p:nvSpPr>
+        <p:spPr>
+          <a:xfrm>
+            <a:off x="804672" y="3922776"/>
+            <a:ext cx="4370832" cy="484632"/>
+          </a:xfrm>
+          <a:prstGeom prst="rect">
+            <a:avLst/>
+          </a:prstGeom>
+          <a:noFill/>
+        </p:spPr>
+        <p:txBody>
+          <a:bodyPr wrap="square">
+            <a:spAutoFit/>
+          </a:bodyPr>
+          <a:lstStyle/>
+          <a:p>
+            <a:pPr algn="l"/>
+            <a:r>
+              <a:rPr sz="1100" b="0">
+                <a:solidFill>
+                  <a:srgbClr val="222831"/>
+                </a:solidFill>
+                <a:latin typeface="Aptos"/>
+              </a:rPr>
+              <a:t>• RNF04 – Retenção prevista: alertas 90 dias; auditoria 365 dias.</a:t>
+            </a:r>
+          </a:p>
+        </p:txBody>
+      </p:sp>
+      <p:sp>
+        <p:nvSpPr>
+          <p:cNvPr id="12" name="TextBox 11"/>
+          <p:cNvSpPr txBox="1"/>
+          <p:nvPr/>
+        </p:nvSpPr>
+        <p:spPr>
+          <a:xfrm>
+            <a:off x="804672" y="4453128"/>
+            <a:ext cx="4370832" cy="484632"/>
+          </a:xfrm>
+          <a:prstGeom prst="rect">
+            <a:avLst/>
+          </a:prstGeom>
+          <a:noFill/>
+        </p:spPr>
+        <p:txBody>
+          <a:bodyPr wrap="square">
+            <a:spAutoFit/>
+          </a:bodyPr>
+          <a:lstStyle/>
+          <a:p>
+            <a:pPr algn="l"/>
+            <a:r>
+              <a:rPr sz="1100" b="0">
+                <a:solidFill>
+                  <a:srgbClr val="222831"/>
+                </a:solidFill>
+                <a:latin typeface="Aptos"/>
+              </a:rPr>
+              <a:t>• RNF05 – Evidências 30 dias; temporários locais 7 dias.</a:t>
+            </a:r>
+          </a:p>
+        </p:txBody>
+      </p:sp>
+      <p:sp>
+        <p:nvSpPr>
+          <p:cNvPr id="13" name="Rounded Rectangle 12"/>
+          <p:cNvSpPr/>
+          <p:nvPr/>
+        </p:nvSpPr>
+        <p:spPr>
+          <a:xfrm>
+            <a:off x="5989320" y="1645920"/>
+            <a:ext cx="4892040" cy="4251960"/>
+          </a:xfrm>
+          <a:prstGeom prst="roundRect">
+            <a:avLst/>
+          </a:prstGeom>
+          <a:solidFill>
+            <a:srgbClr val="FFFFFF"/>
+          </a:solidFill>
+          <a:ln>
+            <a:solidFill>
+              <a:srgbClr val="DEE5EB"/>
+            </a:solidFill>
+          </a:ln>
+        </p:spPr>
+        <p:style>
+          <a:lnRef idx="1">
+            <a:schemeClr val="accent1"/>
+          </a:lnRef>
+          <a:fillRef idx="3">
+            <a:schemeClr val="accent1"/>
+          </a:fillRef>
+          <a:effectRef idx="2">
+            <a:schemeClr val="accent1"/>
+          </a:effectRef>
+          <a:fontRef idx="minor">
+            <a:schemeClr val="lt1"/>
+          </a:fontRef>
+        </p:style>
+        <p:txBody>
+          <a:bodyPr rtlCol="0" anchor="ctr"/>
+          <a:lstStyle/>
+          <a:p>
+            <a:pPr algn="ctr"/>
+          </a:p>
+        </p:txBody>
+      </p:sp>
+      <p:sp>
+        <p:nvSpPr>
+          <p:cNvPr id="14" name="Rectangle 13"/>
+          <p:cNvSpPr/>
+          <p:nvPr/>
+        </p:nvSpPr>
+        <p:spPr>
+          <a:xfrm>
+            <a:off x="5989320" y="1645920"/>
+            <a:ext cx="4892040" cy="64008"/>
+          </a:xfrm>
+          <a:prstGeom prst="rect">
+            <a:avLst/>
+          </a:prstGeom>
+          <a:solidFill>
+            <a:srgbClr val="109E78"/>
+          </a:solidFill>
+          <a:ln>
+            <a:noFill/>
+          </a:ln>
+        </p:spPr>
+        <p:style>
+          <a:lnRef idx="1">
+            <a:schemeClr val="accent1"/>
+          </a:lnRef>
+          <a:fillRef idx="3">
+            <a:schemeClr val="accent1"/>
+          </a:fillRef>
+          <a:effectRef idx="2">
+            <a:schemeClr val="accent1"/>
+          </a:effectRef>
+          <a:fontRef idx="minor">
+            <a:schemeClr val="lt1"/>
+          </a:fontRef>
+        </p:style>
+        <p:txBody>
+          <a:bodyPr rtlCol="0" anchor="ctr"/>
+          <a:lstStyle/>
+          <a:p>
+            <a:pPr algn="ctr"/>
+          </a:p>
+        </p:txBody>
+      </p:sp>
+      <p:sp>
+        <p:nvSpPr>
+          <p:cNvPr id="15" name="TextBox 14"/>
+          <p:cNvSpPr txBox="1"/>
+          <p:nvPr/>
+        </p:nvSpPr>
+        <p:spPr>
+          <a:xfrm>
+            <a:off x="6217920" y="1874519"/>
+            <a:ext cx="4434840" cy="320040"/>
+          </a:xfrm>
+          <a:prstGeom prst="rect">
+            <a:avLst/>
+          </a:prstGeom>
+          <a:noFill/>
+        </p:spPr>
+        <p:txBody>
+          <a:bodyPr wrap="square">
+            <a:spAutoFit/>
+          </a:bodyPr>
+          <a:lstStyle/>
+          <a:p>
+            <a:pPr algn="l"/>
+            <a:r>
+              <a:rPr sz="1500" b="1">
+                <a:solidFill>
+                  <a:srgbClr val="0B2E4D"/>
+                </a:solidFill>
+                <a:latin typeface="Aptos"/>
+              </a:rPr>
+              <a:t>RNF06–RNF10</a:t>
+            </a:r>
+          </a:p>
+        </p:txBody>
+      </p:sp>
+      <p:sp>
+        <p:nvSpPr>
+          <p:cNvPr id="16" name="TextBox 15"/>
+          <p:cNvSpPr txBox="1"/>
+          <p:nvPr/>
+        </p:nvSpPr>
+        <p:spPr>
+          <a:xfrm>
+            <a:off x="6245352" y="2331720"/>
+            <a:ext cx="4370832" cy="484632"/>
+          </a:xfrm>
+          <a:prstGeom prst="rect">
+            <a:avLst/>
+          </a:prstGeom>
+          <a:noFill/>
+        </p:spPr>
+        <p:txBody>
+          <a:bodyPr wrap="square">
+            <a:spAutoFit/>
+          </a:bodyPr>
+          <a:lstStyle/>
+          <a:p>
+            <a:pPr algn="l"/>
+            <a:r>
+              <a:rPr sz="1100" b="0">
+                <a:solidFill>
+                  <a:srgbClr val="222831"/>
+                </a:solidFill>
+                <a:latin typeface="Aptos"/>
+              </a:rPr>
+              <a:t>• RNF06 – Evidência não pode ser sobrescrita pelo cliente.</a:t>
+            </a:r>
+          </a:p>
+        </p:txBody>
+      </p:sp>
+      <p:sp>
+        <p:nvSpPr>
+          <p:cNvPr id="17" name="TextBox 16"/>
+          <p:cNvSpPr txBox="1"/>
+          <p:nvPr/>
+        </p:nvSpPr>
+        <p:spPr>
+          <a:xfrm>
+            <a:off x="6245352" y="2862072"/>
+            <a:ext cx="4370832" cy="484632"/>
+          </a:xfrm>
+          <a:prstGeom prst="rect">
+            <a:avLst/>
+          </a:prstGeom>
+          <a:noFill/>
+        </p:spPr>
+        <p:txBody>
+          <a:bodyPr wrap="square">
+            <a:spAutoFit/>
+          </a:bodyPr>
+          <a:lstStyle/>
+          <a:p>
+            <a:pPr algn="l"/>
+            <a:r>
+              <a:rPr sz="1100" b="0">
+                <a:solidFill>
+                  <a:srgbClr val="222831"/>
+                </a:solidFill>
+                <a:latin typeface="Aptos"/>
+              </a:rPr>
+              <a:t>• RNF07 – Nenhum acesso cruzado entre instituições.</a:t>
+            </a:r>
+          </a:p>
+        </p:txBody>
+      </p:sp>
+      <p:sp>
+        <p:nvSpPr>
+          <p:cNvPr id="18" name="TextBox 17"/>
+          <p:cNvSpPr txBox="1"/>
+          <p:nvPr/>
+        </p:nvSpPr>
+        <p:spPr>
+          <a:xfrm>
+            <a:off x="6245352" y="3392424"/>
+            <a:ext cx="4370832" cy="484632"/>
+          </a:xfrm>
+          <a:prstGeom prst="rect">
+            <a:avLst/>
+          </a:prstGeom>
+          <a:noFill/>
+        </p:spPr>
+        <p:txBody>
+          <a:bodyPr wrap="square">
+            <a:spAutoFit/>
+          </a:bodyPr>
+          <a:lstStyle/>
+          <a:p>
+            <a:pPr algn="l"/>
+            <a:r>
+              <a:rPr sz="1100" b="0">
+                <a:solidFill>
+                  <a:srgbClr val="222831"/>
+                </a:solidFill>
+                <a:latin typeface="Aptos"/>
+              </a:rPr>
+              <a:t>• RNF08 – Modo demonstrativo local independente do Firebase.</a:t>
+            </a:r>
+          </a:p>
+        </p:txBody>
+      </p:sp>
+      <p:sp>
+        <p:nvSpPr>
+          <p:cNvPr id="19" name="TextBox 18"/>
+          <p:cNvSpPr txBox="1"/>
+          <p:nvPr/>
+        </p:nvSpPr>
+        <p:spPr>
+          <a:xfrm>
+            <a:off x="6245352" y="3922776"/>
+            <a:ext cx="4370832" cy="484632"/>
+          </a:xfrm>
+          <a:prstGeom prst="rect">
+            <a:avLst/>
+          </a:prstGeom>
+          <a:noFill/>
+        </p:spPr>
+        <p:txBody>
+          <a:bodyPr wrap="square">
+            <a:spAutoFit/>
+          </a:bodyPr>
+          <a:lstStyle/>
+          <a:p>
+            <a:pPr algn="l"/>
+            <a:r>
+              <a:rPr sz="1100" b="0">
+                <a:solidFill>
+                  <a:srgbClr val="222831"/>
+                </a:solidFill>
+                <a:latin typeface="Aptos"/>
+              </a:rPr>
+              <a:t>• RNF09 – Permissões necessárias e confirmação clara ao usuário.</a:t>
+            </a:r>
+          </a:p>
+        </p:txBody>
+      </p:sp>
+      <p:sp>
+        <p:nvSpPr>
+          <p:cNvPr id="20" name="TextBox 19"/>
+          <p:cNvSpPr txBox="1"/>
+          <p:nvPr/>
+        </p:nvSpPr>
+        <p:spPr>
+          <a:xfrm>
+            <a:off x="6245352" y="4453128"/>
+            <a:ext cx="4370832" cy="484632"/>
+          </a:xfrm>
+          <a:prstGeom prst="rect">
+            <a:avLst/>
+          </a:prstGeom>
+          <a:noFill/>
+        </p:spPr>
+        <p:txBody>
+          <a:bodyPr wrap="square">
+            <a:spAutoFit/>
+          </a:bodyPr>
+          <a:lstStyle/>
+          <a:p>
+            <a:pPr algn="l"/>
+            <a:r>
+              <a:rPr sz="1100" b="0">
+                <a:solidFill>
+                  <a:srgbClr val="222831"/>
+                </a:solidFill>
+                <a:latin typeface="Aptos"/>
+              </a:rPr>
+              <a:t>• RNF10 – MySQL futuro somente via API/backend seguro.</a:t>
+            </a:r>
+          </a:p>
+        </p:txBody>
+      </p:sp>
+      <p:sp>
+        <p:nvSpPr>
+          <p:cNvPr id="21" name="Rectangle 20"/>
+          <p:cNvSpPr/>
+          <p:nvPr/>
+        </p:nvSpPr>
+        <p:spPr>
+          <a:xfrm>
+            <a:off x="548640" y="6446520"/>
+            <a:ext cx="10287000" cy="10972"/>
+          </a:xfrm>
+          <a:prstGeom prst="rect">
+            <a:avLst/>
+          </a:prstGeom>
+          <a:solidFill>
+            <a:srgbClr val="DCE2E8"/>
+          </a:solidFill>
+          <a:ln>
+            <a:noFill/>
+          </a:ln>
+        </p:spPr>
+        <p:style>
+          <a:lnRef idx="1">
+            <a:schemeClr val="accent1"/>
+          </a:lnRef>
+          <a:fillRef idx="3">
+            <a:schemeClr val="accent1"/>
+          </a:fillRef>
+          <a:effectRef idx="2">
+            <a:schemeClr val="accent1"/>
+          </a:effectRef>
+          <a:fontRef idx="minor">
+            <a:schemeClr val="lt1"/>
+          </a:fontRef>
+        </p:style>
+        <p:txBody>
+          <a:bodyPr rtlCol="0" anchor="ctr"/>
+          <a:lstStyle/>
+          <a:p>
+            <a:pPr algn="ctr"/>
+          </a:p>
+        </p:txBody>
+      </p:sp>
+      <p:sp>
+        <p:nvSpPr>
+          <p:cNvPr id="22" name="TextBox 21"/>
+          <p:cNvSpPr txBox="1"/>
+          <p:nvPr/>
+        </p:nvSpPr>
+        <p:spPr>
+          <a:xfrm>
+            <a:off x="548640" y="6510528"/>
+            <a:ext cx="5029200" cy="182880"/>
+          </a:xfrm>
+          <a:prstGeom prst="rect">
+            <a:avLst/>
+          </a:prstGeom>
+          <a:noFill/>
+        </p:spPr>
+        <p:txBody>
+          <a:bodyPr wrap="square">
+            <a:spAutoFit/>
+          </a:bodyPr>
+          <a:lstStyle/>
+          <a:p>
+            <a:pPr algn="l"/>
+            <a:r>
+              <a:rPr sz="800" b="0">
+                <a:solidFill>
+                  <a:srgbClr val="646E78"/>
+                </a:solidFill>
+                <a:latin typeface="Aptos"/>
+              </a:rPr>
+              <a:t>PROTÓTIPO ACADÊMICO • DADOS DEMONSTRATIVOS</a:t>
+            </a:r>
+          </a:p>
+        </p:txBody>
+      </p:sp>
+      <p:sp>
+        <p:nvSpPr>
+          <p:cNvPr id="23" name="TextBox 22"/>
+          <p:cNvSpPr txBox="1"/>
+          <p:nvPr/>
+        </p:nvSpPr>
+        <p:spPr>
+          <a:xfrm>
+            <a:off x="10442448" y="6473952"/>
+            <a:ext cx="365760" cy="228600"/>
+          </a:xfrm>
+          <a:prstGeom prst="rect">
+            <a:avLst/>
+          </a:prstGeom>
+          <a:noFill/>
+        </p:spPr>
+        <p:txBody>
+          <a:bodyPr wrap="square">
+            <a:spAutoFit/>
+          </a:bodyPr>
+          <a:lstStyle/>
+          <a:p>
+            <a:pPr algn="r"/>
+            <a:r>
+              <a:rPr sz="800" b="0">
+                <a:solidFill>
+                  <a:srgbClr val="646E78"/>
+                </a:solidFill>
+                <a:latin typeface="Aptos"/>
+              </a:rPr>
+              <a:t>14</a:t>
+            </a:r>
+          </a:p>
+        </p:txBody>
+      </p:sp>
+    </p:spTree>
+  </p:cSld>
+  <p:clrMapOvr>
+    <a:masterClrMapping/>
+  </p:clrMapOvr>
+</p:sld>
+</file>
+
+<file path=ppt/slides/slide15.xml><?xml version="1.0" encoding="utf-8"?>
+<p:sld xmlns:a="http://schemas.openxmlformats.org/drawingml/2006/main" xmlns:p="http://schemas.openxmlformats.org/presentationml/2006/main" xmlns:r="http://schemas.openxmlformats.org/officeDocument/2006/relationships">
+  <p:cSld>
+    <p:bg>
+      <p:bgPr>
+        <a:solidFill>
+          <a:srgbClr val="F4F8FB"/>
+        </a:solidFill>
+        <a:effectLst/>
+      </p:bgPr>
+    </p:bg>
+    <p:spTree>
+      <p:nvGrpSpPr>
+        <p:cNvPr id="1" name=""/>
+        <p:cNvGrpSpPr/>
+        <p:nvPr/>
+      </p:nvGrpSpPr>
+      <p:grpSpPr/>
+      <p:sp>
+        <p:nvSpPr>
+          <p:cNvPr id="2" name="Rectangle 1"/>
+          <p:cNvSpPr/>
+          <p:nvPr/>
+        </p:nvSpPr>
+        <p:spPr>
+          <a:xfrm>
+            <a:off x="548640" y="411480"/>
+            <a:ext cx="1280160" cy="36576"/>
+          </a:xfrm>
+          <a:prstGeom prst="rect">
+            <a:avLst/>
+          </a:prstGeom>
+          <a:solidFill>
+            <a:srgbClr val="12B5CB"/>
+          </a:solidFill>
+          <a:ln>
+            <a:noFill/>
+          </a:ln>
+        </p:spPr>
+        <p:style>
+          <a:lnRef idx="1">
+            <a:schemeClr val="accent1"/>
+          </a:lnRef>
+          <a:fillRef idx="3">
+            <a:schemeClr val="accent1"/>
+          </a:fillRef>
+          <a:effectRef idx="2">
+            <a:schemeClr val="accent1"/>
+          </a:effectRef>
+          <a:fontRef idx="minor">
+            <a:schemeClr val="lt1"/>
+          </a:fontRef>
+        </p:style>
+        <p:txBody>
+          <a:bodyPr rtlCol="0" anchor="ctr"/>
+          <a:lstStyle/>
+          <a:p>
+            <a:pPr algn="ctr"/>
+          </a:p>
+        </p:txBody>
+      </p:sp>
+      <p:sp>
+        <p:nvSpPr>
+          <p:cNvPr id="3" name="TextBox 2"/>
+          <p:cNvSpPr txBox="1"/>
+          <p:nvPr/>
+        </p:nvSpPr>
+        <p:spPr>
+          <a:xfrm>
+            <a:off x="548640" y="530352"/>
+            <a:ext cx="2560320" cy="228600"/>
+          </a:xfrm>
+          <a:prstGeom prst="rect">
+            <a:avLst/>
+          </a:prstGeom>
+          <a:noFill/>
+        </p:spPr>
+        <p:txBody>
+          <a:bodyPr wrap="square">
+            <a:spAutoFit/>
+          </a:bodyPr>
+          <a:lstStyle/>
+          <a:p>
+            <a:pPr algn="l"/>
+            <a:r>
+              <a:rPr sz="1000" b="1">
+                <a:solidFill>
+                  <a:srgbClr val="12B5CB"/>
+                </a:solidFill>
+                <a:latin typeface="Aptos"/>
+              </a:rPr>
+              <a:t>NEGÓCIO</a:t>
+            </a:r>
+          </a:p>
+        </p:txBody>
+      </p:sp>
+      <p:sp>
+        <p:nvSpPr>
+          <p:cNvPr id="4" name="TextBox 3"/>
+          <p:cNvSpPr txBox="1"/>
+          <p:nvPr/>
+        </p:nvSpPr>
+        <p:spPr>
+          <a:xfrm>
+            <a:off x="548640" y="868680"/>
+            <a:ext cx="10332720" cy="548640"/>
+          </a:xfrm>
+          <a:prstGeom prst="rect">
+            <a:avLst/>
+          </a:prstGeom>
+          <a:noFill/>
+        </p:spPr>
+        <p:txBody>
+          <a:bodyPr wrap="square">
+            <a:spAutoFit/>
+          </a:bodyPr>
+          <a:lstStyle/>
+          <a:p>
+            <a:pPr algn="l"/>
+            <a:r>
+              <a:rPr sz="2700" b="1">
+                <a:solidFill>
+                  <a:srgbClr val="0B2E4D"/>
+                </a:solidFill>
+                <a:latin typeface="Aptos"/>
+              </a:rPr>
+              <a:t>Regras de negócio aplicadas</a:t>
+            </a:r>
+          </a:p>
+        </p:txBody>
+      </p:sp>
+      <p:sp>
+        <p:nvSpPr>
+          <p:cNvPr id="5" name="Rounded Rectangle 4"/>
+          <p:cNvSpPr/>
+          <p:nvPr/>
+        </p:nvSpPr>
+        <p:spPr>
+          <a:xfrm>
+            <a:off x="548640" y="1645920"/>
+            <a:ext cx="4892040" cy="4251960"/>
+          </a:xfrm>
+          <a:prstGeom prst="roundRect">
+            <a:avLst/>
+          </a:prstGeom>
+          <a:solidFill>
+            <a:srgbClr val="FFFFFF"/>
+          </a:solidFill>
+          <a:ln>
+            <a:solidFill>
+              <a:srgbClr val="DEE5EB"/>
+            </a:solidFill>
+          </a:ln>
+        </p:spPr>
+        <p:style>
+          <a:lnRef idx="1">
+            <a:schemeClr val="accent1"/>
+          </a:lnRef>
+          <a:fillRef idx="3">
+            <a:schemeClr val="accent1"/>
+          </a:fillRef>
+          <a:effectRef idx="2">
+            <a:schemeClr val="accent1"/>
+          </a:effectRef>
+          <a:fontRef idx="minor">
+            <a:schemeClr val="lt1"/>
+          </a:fontRef>
+        </p:style>
+        <p:txBody>
+          <a:bodyPr rtlCol="0" anchor="ctr"/>
+          <a:lstStyle/>
+          <a:p>
+            <a:pPr algn="ctr"/>
+          </a:p>
+        </p:txBody>
+      </p:sp>
+      <p:sp>
+        <p:nvSpPr>
+          <p:cNvPr id="6" name="Rectangle 5"/>
+          <p:cNvSpPr/>
+          <p:nvPr/>
+        </p:nvSpPr>
+        <p:spPr>
+          <a:xfrm>
+            <a:off x="548640" y="1645920"/>
+            <a:ext cx="4892040" cy="64008"/>
+          </a:xfrm>
+          <a:prstGeom prst="rect">
+            <a:avLst/>
+          </a:prstGeom>
+          <a:solidFill>
+            <a:srgbClr val="0078B5"/>
+          </a:solidFill>
+          <a:ln>
+            <a:noFill/>
+          </a:ln>
+        </p:spPr>
+        <p:style>
+          <a:lnRef idx="1">
+            <a:schemeClr val="accent1"/>
+          </a:lnRef>
+          <a:fillRef idx="3">
+            <a:schemeClr val="accent1"/>
+          </a:fillRef>
+          <a:effectRef idx="2">
+            <a:schemeClr val="accent1"/>
+          </a:effectRef>
+          <a:fontRef idx="minor">
+            <a:schemeClr val="lt1"/>
+          </a:fontRef>
+        </p:style>
+        <p:txBody>
+          <a:bodyPr rtlCol="0" anchor="ctr"/>
+          <a:lstStyle/>
+          <a:p>
+            <a:pPr algn="ctr"/>
+          </a:p>
+        </p:txBody>
+      </p:sp>
+      <p:sp>
+        <p:nvSpPr>
+          <p:cNvPr id="7" name="TextBox 6"/>
+          <p:cNvSpPr txBox="1"/>
+          <p:nvPr/>
+        </p:nvSpPr>
+        <p:spPr>
+          <a:xfrm>
+            <a:off x="777240" y="1874519"/>
+            <a:ext cx="4434840" cy="320040"/>
+          </a:xfrm>
+          <a:prstGeom prst="rect">
+            <a:avLst/>
+          </a:prstGeom>
+          <a:noFill/>
+        </p:spPr>
+        <p:txBody>
+          <a:bodyPr wrap="square">
+            <a:spAutoFit/>
+          </a:bodyPr>
+          <a:lstStyle/>
+          <a:p>
+            <a:pPr algn="l"/>
+            <a:r>
+              <a:rPr sz="1500" b="1">
+                <a:solidFill>
+                  <a:srgbClr val="0B2E4D"/>
+                </a:solidFill>
+                <a:latin typeface="Aptos"/>
+              </a:rPr>
+              <a:t>RN01–RN06</a:t>
+            </a:r>
+          </a:p>
+        </p:txBody>
+      </p:sp>
+      <p:sp>
+        <p:nvSpPr>
+          <p:cNvPr id="8" name="TextBox 7"/>
+          <p:cNvSpPr txBox="1"/>
+          <p:nvPr/>
+        </p:nvSpPr>
+        <p:spPr>
+          <a:xfrm>
+            <a:off x="804672" y="2331720"/>
+            <a:ext cx="4370832" cy="484632"/>
+          </a:xfrm>
+          <a:prstGeom prst="rect">
+            <a:avLst/>
+          </a:prstGeom>
+          <a:noFill/>
+        </p:spPr>
+        <p:txBody>
+          <a:bodyPr wrap="square">
+            <a:spAutoFit/>
+          </a:bodyPr>
+          <a:lstStyle/>
+          <a:p>
+            <a:pPr algn="l"/>
+            <a:r>
+              <a:rPr sz="1100" b="0">
+                <a:solidFill>
+                  <a:srgbClr val="222831"/>
+                </a:solidFill>
+                <a:latin typeface="Aptos"/>
+              </a:rPr>
+              <a:t>• RN01 – E-mail deve estar verificado para operar.</a:t>
+            </a:r>
+          </a:p>
+        </p:txBody>
+      </p:sp>
+      <p:sp>
+        <p:nvSpPr>
+          <p:cNvPr id="9" name="TextBox 8"/>
+          <p:cNvSpPr txBox="1"/>
+          <p:nvPr/>
+        </p:nvSpPr>
+        <p:spPr>
+          <a:xfrm>
+            <a:off x="804672" y="2862072"/>
+            <a:ext cx="4370832" cy="484632"/>
+          </a:xfrm>
+          <a:prstGeom prst="rect">
+            <a:avLst/>
+          </a:prstGeom>
+          <a:noFill/>
+        </p:spPr>
+        <p:txBody>
+          <a:bodyPr wrap="square">
+            <a:spAutoFit/>
+          </a:bodyPr>
+          <a:lstStyle/>
+          <a:p>
+            <a:pPr algn="l"/>
+            <a:r>
+              <a:rPr sz="1100" b="0">
+                <a:solidFill>
+                  <a:srgbClr val="222831"/>
+                </a:solidFill>
+                <a:latin typeface="Aptos"/>
+              </a:rPr>
+              <a:t>• RN02 – Membership ativa e institutionId são obrigatórios.</a:t>
+            </a:r>
+          </a:p>
+        </p:txBody>
+      </p:sp>
+      <p:sp>
+        <p:nvSpPr>
+          <p:cNvPr id="10" name="TextBox 9"/>
+          <p:cNvSpPr txBox="1"/>
+          <p:nvPr/>
+        </p:nvSpPr>
+        <p:spPr>
+          <a:xfrm>
+            <a:off x="804672" y="3392424"/>
+            <a:ext cx="4370832" cy="484632"/>
+          </a:xfrm>
+          <a:prstGeom prst="rect">
+            <a:avLst/>
+          </a:prstGeom>
+          <a:noFill/>
+        </p:spPr>
+        <p:txBody>
+          <a:bodyPr wrap="square">
+            <a:spAutoFit/>
+          </a:bodyPr>
+          <a:lstStyle/>
+          <a:p>
+            <a:pPr algn="l"/>
+            <a:r>
+              <a:rPr sz="1100" b="0">
+                <a:solidFill>
+                  <a:srgbClr val="222831"/>
+                </a:solidFill>
+                <a:latin typeface="Aptos"/>
+              </a:rPr>
+              <a:t>• RN03 – Operador atua somente na própria instituição.</a:t>
+            </a:r>
+          </a:p>
+        </p:txBody>
+      </p:sp>
+      <p:sp>
+        <p:nvSpPr>
+          <p:cNvPr id="11" name="TextBox 10"/>
+          <p:cNvSpPr txBox="1"/>
+          <p:nvPr/>
+        </p:nvSpPr>
+        <p:spPr>
+          <a:xfrm>
+            <a:off x="804672" y="3922776"/>
+            <a:ext cx="4370832" cy="484632"/>
+          </a:xfrm>
+          <a:prstGeom prst="rect">
+            <a:avLst/>
+          </a:prstGeom>
+          <a:noFill/>
+        </p:spPr>
+        <p:txBody>
+          <a:bodyPr wrap="square">
+            <a:spAutoFit/>
+          </a:bodyPr>
+          <a:lstStyle/>
+          <a:p>
+            <a:pPr algn="l"/>
+            <a:r>
+              <a:rPr sz="1100" b="0">
+                <a:solidFill>
+                  <a:srgbClr val="222831"/>
+                </a:solidFill>
+                <a:latin typeface="Aptos"/>
+              </a:rPr>
+              <a:t>• RN04 – Máximo de 1 alerta ativo por usuário.</a:t>
+            </a:r>
+          </a:p>
+        </p:txBody>
+      </p:sp>
+      <p:sp>
+        <p:nvSpPr>
+          <p:cNvPr id="12" name="TextBox 11"/>
+          <p:cNvSpPr txBox="1"/>
+          <p:nvPr/>
+        </p:nvSpPr>
+        <p:spPr>
+          <a:xfrm>
+            <a:off x="804672" y="4453128"/>
+            <a:ext cx="4370832" cy="484632"/>
+          </a:xfrm>
+          <a:prstGeom prst="rect">
+            <a:avLst/>
+          </a:prstGeom>
+          <a:noFill/>
+        </p:spPr>
+        <p:txBody>
+          <a:bodyPr wrap="square">
+            <a:spAutoFit/>
+          </a:bodyPr>
+          <a:lstStyle/>
+          <a:p>
+            <a:pPr algn="l"/>
+            <a:r>
+              <a:rPr sz="1100" b="0">
+                <a:solidFill>
+                  <a:srgbClr val="222831"/>
+                </a:solidFill>
+                <a:latin typeface="Aptos"/>
+              </a:rPr>
+              <a:t>• RN05 – Máximo de 3 alertas em 30 minutos.</a:t>
+            </a:r>
+          </a:p>
+        </p:txBody>
+      </p:sp>
+      <p:sp>
+        <p:nvSpPr>
+          <p:cNvPr id="13" name="TextBox 12"/>
+          <p:cNvSpPr txBox="1"/>
+          <p:nvPr/>
+        </p:nvSpPr>
+        <p:spPr>
+          <a:xfrm>
+            <a:off x="804672" y="4983480"/>
+            <a:ext cx="4370832" cy="484632"/>
+          </a:xfrm>
+          <a:prstGeom prst="rect">
+            <a:avLst/>
+          </a:prstGeom>
+          <a:noFill/>
+        </p:spPr>
+        <p:txBody>
+          <a:bodyPr wrap="square">
+            <a:spAutoFit/>
+          </a:bodyPr>
+          <a:lstStyle/>
+          <a:p>
+            <a:pPr algn="l"/>
+            <a:r>
+              <a:rPr sz="1100" b="0">
+                <a:solidFill>
+                  <a:srgbClr val="222831"/>
+                </a:solidFill>
+                <a:latin typeface="Aptos"/>
+              </a:rPr>
+              <a:t>• RN06 – Intervalo mínimo de 60 segundos entre novos alertas.</a:t>
+            </a:r>
+          </a:p>
+        </p:txBody>
+      </p:sp>
+      <p:sp>
+        <p:nvSpPr>
+          <p:cNvPr id="14" name="Rounded Rectangle 13"/>
+          <p:cNvSpPr/>
+          <p:nvPr/>
+        </p:nvSpPr>
+        <p:spPr>
+          <a:xfrm>
+            <a:off x="5989320" y="1645920"/>
+            <a:ext cx="4892040" cy="4251960"/>
+          </a:xfrm>
+          <a:prstGeom prst="roundRect">
+            <a:avLst/>
+          </a:prstGeom>
+          <a:solidFill>
+            <a:srgbClr val="FFFFFF"/>
+          </a:solidFill>
+          <a:ln>
+            <a:solidFill>
+              <a:srgbClr val="DEE5EB"/>
+            </a:solidFill>
+          </a:ln>
+        </p:spPr>
+        <p:style>
+          <a:lnRef idx="1">
+            <a:schemeClr val="accent1"/>
+          </a:lnRef>
+          <a:fillRef idx="3">
+            <a:schemeClr val="accent1"/>
+          </a:fillRef>
+          <a:effectRef idx="2">
+            <a:schemeClr val="accent1"/>
+          </a:effectRef>
+          <a:fontRef idx="minor">
+            <a:schemeClr val="lt1"/>
+          </a:fontRef>
+        </p:style>
+        <p:txBody>
+          <a:bodyPr rtlCol="0" anchor="ctr"/>
+          <a:lstStyle/>
+          <a:p>
+            <a:pPr algn="ctr"/>
+          </a:p>
+        </p:txBody>
+      </p:sp>
+      <p:sp>
+        <p:nvSpPr>
+          <p:cNvPr id="15" name="Rectangle 14"/>
+          <p:cNvSpPr/>
+          <p:nvPr/>
+        </p:nvSpPr>
+        <p:spPr>
+          <a:xfrm>
+            <a:off x="5989320" y="1645920"/>
+            <a:ext cx="4892040" cy="64008"/>
+          </a:xfrm>
+          <a:prstGeom prst="rect">
+            <a:avLst/>
+          </a:prstGeom>
+          <a:solidFill>
+            <a:srgbClr val="109E78"/>
+          </a:solidFill>
+          <a:ln>
+            <a:noFill/>
+          </a:ln>
+        </p:spPr>
+        <p:style>
+          <a:lnRef idx="1">
+            <a:schemeClr val="accent1"/>
+          </a:lnRef>
+          <a:fillRef idx="3">
+            <a:schemeClr val="accent1"/>
+          </a:fillRef>
+          <a:effectRef idx="2">
+            <a:schemeClr val="accent1"/>
+          </a:effectRef>
+          <a:fontRef idx="minor">
+            <a:schemeClr val="lt1"/>
+          </a:fontRef>
+        </p:style>
+        <p:txBody>
+          <a:bodyPr rtlCol="0" anchor="ctr"/>
+          <a:lstStyle/>
+          <a:p>
+            <a:pPr algn="ctr"/>
+          </a:p>
+        </p:txBody>
+      </p:sp>
+      <p:sp>
+        <p:nvSpPr>
+          <p:cNvPr id="16" name="TextBox 15"/>
+          <p:cNvSpPr txBox="1"/>
+          <p:nvPr/>
+        </p:nvSpPr>
+        <p:spPr>
+          <a:xfrm>
+            <a:off x="6217920" y="1874519"/>
+            <a:ext cx="4434840" cy="320040"/>
+          </a:xfrm>
+          <a:prstGeom prst="rect">
+            <a:avLst/>
+          </a:prstGeom>
+          <a:noFill/>
+        </p:spPr>
+        <p:txBody>
+          <a:bodyPr wrap="square">
+            <a:spAutoFit/>
+          </a:bodyPr>
+          <a:lstStyle/>
+          <a:p>
+            <a:pPr algn="l"/>
+            <a:r>
+              <a:rPr sz="1500" b="1">
+                <a:solidFill>
+                  <a:srgbClr val="0B2E4D"/>
+                </a:solidFill>
+                <a:latin typeface="Aptos"/>
+              </a:rPr>
+              <a:t>RN07–RN12</a:t>
+            </a:r>
+          </a:p>
+        </p:txBody>
+      </p:sp>
+      <p:sp>
+        <p:nvSpPr>
+          <p:cNvPr id="17" name="TextBox 16"/>
+          <p:cNvSpPr txBox="1"/>
+          <p:nvPr/>
+        </p:nvSpPr>
+        <p:spPr>
+          <a:xfrm>
+            <a:off x="6245352" y="2331720"/>
+            <a:ext cx="4370832" cy="484632"/>
+          </a:xfrm>
+          <a:prstGeom prst="rect">
+            <a:avLst/>
+          </a:prstGeom>
+          <a:noFill/>
+        </p:spPr>
+        <p:txBody>
+          <a:bodyPr wrap="square">
+            <a:spAutoFit/>
+          </a:bodyPr>
+          <a:lstStyle/>
+          <a:p>
+            <a:pPr algn="l"/>
+            <a:r>
+              <a:rPr sz="1100" b="0">
+                <a:solidFill>
+                  <a:srgbClr val="222831"/>
+                </a:solidFill>
+                <a:latin typeface="Aptos"/>
+              </a:rPr>
+              <a:t>• RN07 – Evidência enviada não pode ser substituída.</a:t>
+            </a:r>
+          </a:p>
+        </p:txBody>
+      </p:sp>
+      <p:sp>
+        <p:nvSpPr>
+          <p:cNvPr id="18" name="TextBox 17"/>
+          <p:cNvSpPr txBox="1"/>
+          <p:nvPr/>
+        </p:nvSpPr>
+        <p:spPr>
+          <a:xfrm>
+            <a:off x="6245352" y="2862072"/>
+            <a:ext cx="4370832" cy="484632"/>
+          </a:xfrm>
+          <a:prstGeom prst="rect">
+            <a:avLst/>
+          </a:prstGeom>
+          <a:noFill/>
+        </p:spPr>
+        <p:txBody>
+          <a:bodyPr wrap="square">
+            <a:spAutoFit/>
+          </a:bodyPr>
+          <a:lstStyle/>
+          <a:p>
+            <a:pPr algn="l"/>
+            <a:r>
+              <a:rPr sz="1100" b="0">
+                <a:solidFill>
+                  <a:srgbClr val="222831"/>
+                </a:solidFill>
+                <a:latin typeface="Aptos"/>
+              </a:rPr>
+              <a:t>• RN08 – medicalNotes e dados clínicos são proibidos.</a:t>
+            </a:r>
+          </a:p>
+        </p:txBody>
+      </p:sp>
+      <p:sp>
+        <p:nvSpPr>
+          <p:cNvPr id="19" name="TextBox 18"/>
+          <p:cNvSpPr txBox="1"/>
+          <p:nvPr/>
+        </p:nvSpPr>
+        <p:spPr>
+          <a:xfrm>
+            <a:off x="6245352" y="3392424"/>
+            <a:ext cx="4370832" cy="484632"/>
+          </a:xfrm>
+          <a:prstGeom prst="rect">
+            <a:avLst/>
+          </a:prstGeom>
+          <a:noFill/>
+        </p:spPr>
+        <p:txBody>
+          <a:bodyPr wrap="square">
+            <a:spAutoFit/>
+          </a:bodyPr>
+          <a:lstStyle/>
+          <a:p>
+            <a:pPr algn="l"/>
+            <a:r>
+              <a:rPr sz="1100" b="0">
+                <a:solidFill>
+                  <a:srgbClr val="222831"/>
+                </a:solidFill>
+                <a:latin typeface="Aptos"/>
+              </a:rPr>
+              <a:t>• RN09 – Auditoria registra ator, alerta, instituição e horário.</a:t>
+            </a:r>
+          </a:p>
+        </p:txBody>
+      </p:sp>
+      <p:sp>
+        <p:nvSpPr>
+          <p:cNvPr id="20" name="TextBox 19"/>
+          <p:cNvSpPr txBox="1"/>
+          <p:nvPr/>
+        </p:nvSpPr>
+        <p:spPr>
+          <a:xfrm>
+            <a:off x="6245352" y="3922776"/>
+            <a:ext cx="4370832" cy="484632"/>
+          </a:xfrm>
+          <a:prstGeom prst="rect">
+            <a:avLst/>
+          </a:prstGeom>
+          <a:noFill/>
+        </p:spPr>
+        <p:txBody>
+          <a:bodyPr wrap="square">
+            <a:spAutoFit/>
+          </a:bodyPr>
+          <a:lstStyle/>
+          <a:p>
+            <a:pPr algn="l"/>
+            <a:r>
+              <a:rPr sz="1100" b="0">
+                <a:solidFill>
+                  <a:srgbClr val="222831"/>
+                </a:solidFill>
+                <a:latin typeface="Aptos"/>
+              </a:rPr>
+              <a:t>• RN10 – Exclusão antecipada exige processo administrativo auditável.</a:t>
+            </a:r>
+          </a:p>
+        </p:txBody>
+      </p:sp>
+      <p:sp>
+        <p:nvSpPr>
+          <p:cNvPr id="21" name="TextBox 20"/>
+          <p:cNvSpPr txBox="1"/>
+          <p:nvPr/>
+        </p:nvSpPr>
+        <p:spPr>
+          <a:xfrm>
+            <a:off x="6245352" y="4453128"/>
+            <a:ext cx="4370832" cy="484632"/>
+          </a:xfrm>
+          <a:prstGeom prst="rect">
+            <a:avLst/>
+          </a:prstGeom>
+          <a:noFill/>
+        </p:spPr>
+        <p:txBody>
+          <a:bodyPr wrap="square">
+            <a:spAutoFit/>
+          </a:bodyPr>
+          <a:lstStyle/>
+          <a:p>
+            <a:pPr algn="l"/>
+            <a:r>
+              <a:rPr sz="1100" b="0">
+                <a:solidFill>
+                  <a:srgbClr val="222831"/>
+                </a:solidFill>
+                <a:latin typeface="Aptos"/>
+              </a:rPr>
+              <a:t>• RN11 – Legado sem institutionId/retentionExpiresAt deve ser migrado ou isolado.</a:t>
+            </a:r>
+          </a:p>
+        </p:txBody>
+      </p:sp>
+      <p:sp>
+        <p:nvSpPr>
+          <p:cNvPr id="22" name="TextBox 21"/>
+          <p:cNvSpPr txBox="1"/>
+          <p:nvPr/>
+        </p:nvSpPr>
+        <p:spPr>
+          <a:xfrm>
+            <a:off x="6245352" y="4983480"/>
+            <a:ext cx="4370832" cy="484632"/>
+          </a:xfrm>
+          <a:prstGeom prst="rect">
+            <a:avLst/>
+          </a:prstGeom>
+          <a:noFill/>
+        </p:spPr>
+        <p:txBody>
+          <a:bodyPr wrap="square">
+            <a:spAutoFit/>
+          </a:bodyPr>
+          <a:lstStyle/>
+          <a:p>
+            <a:pPr algn="l"/>
+            <a:r>
+              <a:rPr sz="1100" b="0">
+                <a:solidFill>
+                  <a:srgbClr val="222831"/>
+                </a:solidFill>
+                <a:latin typeface="Aptos"/>
+              </a:rPr>
+              <a:t>• RN12 – Em validação pública, utilizar somente dados fictícios.</a:t>
+            </a:r>
+          </a:p>
+        </p:txBody>
+      </p:sp>
+      <p:sp>
+        <p:nvSpPr>
+          <p:cNvPr id="23" name="Rectangle 22"/>
+          <p:cNvSpPr/>
+          <p:nvPr/>
+        </p:nvSpPr>
+        <p:spPr>
+          <a:xfrm>
+            <a:off x="548640" y="6446520"/>
+            <a:ext cx="10287000" cy="10972"/>
+          </a:xfrm>
+          <a:prstGeom prst="rect">
+            <a:avLst/>
+          </a:prstGeom>
+          <a:solidFill>
+            <a:srgbClr val="DCE2E8"/>
+          </a:solidFill>
+          <a:ln>
+            <a:noFill/>
+          </a:ln>
+        </p:spPr>
+        <p:style>
+          <a:lnRef idx="1">
+            <a:schemeClr val="accent1"/>
+          </a:lnRef>
+          <a:fillRef idx="3">
+            <a:schemeClr val="accent1"/>
+          </a:fillRef>
+          <a:effectRef idx="2">
+            <a:schemeClr val="accent1"/>
+          </a:effectRef>
+          <a:fontRef idx="minor">
+            <a:schemeClr val="lt1"/>
+          </a:fontRef>
+        </p:style>
+        <p:txBody>
+          <a:bodyPr rtlCol="0" anchor="ctr"/>
+          <a:lstStyle/>
+          <a:p>
+            <a:pPr algn="ctr"/>
+          </a:p>
+        </p:txBody>
+      </p:sp>
+      <p:sp>
+        <p:nvSpPr>
+          <p:cNvPr id="24" name="TextBox 23"/>
+          <p:cNvSpPr txBox="1"/>
+          <p:nvPr/>
+        </p:nvSpPr>
+        <p:spPr>
+          <a:xfrm>
+            <a:off x="548640" y="6510528"/>
+            <a:ext cx="5029200" cy="182880"/>
+          </a:xfrm>
+          <a:prstGeom prst="rect">
+            <a:avLst/>
+          </a:prstGeom>
+          <a:noFill/>
+        </p:spPr>
+        <p:txBody>
+          <a:bodyPr wrap="square">
+            <a:spAutoFit/>
+          </a:bodyPr>
+          <a:lstStyle/>
+          <a:p>
+            <a:pPr algn="l"/>
+            <a:r>
+              <a:rPr sz="800" b="0">
+                <a:solidFill>
+                  <a:srgbClr val="646E78"/>
+                </a:solidFill>
+                <a:latin typeface="Aptos"/>
+              </a:rPr>
+              <a:t>PROTÓTIPO ACADÊMICO • DADOS DEMONSTRATIVOS</a:t>
+            </a:r>
+          </a:p>
+        </p:txBody>
+      </p:sp>
+      <p:sp>
+        <p:nvSpPr>
+          <p:cNvPr id="25" name="TextBox 24"/>
+          <p:cNvSpPr txBox="1"/>
+          <p:nvPr/>
+        </p:nvSpPr>
+        <p:spPr>
+          <a:xfrm>
+            <a:off x="10442448" y="6473952"/>
+            <a:ext cx="365760" cy="228600"/>
+          </a:xfrm>
+          <a:prstGeom prst="rect">
+            <a:avLst/>
+          </a:prstGeom>
+          <a:noFill/>
+        </p:spPr>
+        <p:txBody>
+          <a:bodyPr wrap="square">
+            <a:spAutoFit/>
+          </a:bodyPr>
+          <a:lstStyle/>
+          <a:p>
+            <a:pPr algn="r"/>
+            <a:r>
+              <a:rPr sz="800" b="0">
+                <a:solidFill>
+                  <a:srgbClr val="646E78"/>
+                </a:solidFill>
+                <a:latin typeface="Aptos"/>
+              </a:rPr>
+              <a:t>15</a:t>
+            </a:r>
+          </a:p>
+        </p:txBody>
+      </p:sp>
+    </p:spTree>
+  </p:cSld>
+  <p:clrMapOvr>
+    <a:masterClrMapping/>
+  </p:clrMapOvr>
+</p:sld>
+</file>
+
 <file path=ppt/slides/slide2.xml><?xml version="1.0" encoding="utf-8"?>
 <p:sld xmlns:p="http://schemas.openxmlformats.org/presentationml/2006/main">
   <p:cSld>
@@ -9814,19 +12413,8 @@
           </a:bodyPr>
           <a:lstStyle xmlns:a="http://schemas.openxmlformats.org/drawingml/2006/main"/>
           <a:p xmlns:a="http://schemas.openxmlformats.org/drawingml/2006/main">
-            <a:pPr algn="ctr">
-              <a:buNone/>
-              <a:defRPr sz="1200" b="0">
-                <a:solidFill>
-                  <a:srgbClr val="FFFFFF"/>
-                </a:solidFill>
-                <a:latin typeface="Aptos"/>
-                <a:ea typeface="Aptos"/>
-                <a:cs typeface="Aptos"/>
-              </a:defRPr>
-            </a:pPr>
-            <a:r>
-              <a:t>Cadastro, contexto e consentimento</a:t>
+            <a:r>
+              <a:t>Cadastro, verificação e vínculo</a:t>
             </a:r>
           </a:p>
         </p:txBody>
@@ -10206,19 +12794,8 @@
           </a:bodyPr>
           <a:lstStyle xmlns:a="http://schemas.openxmlformats.org/drawingml/2006/main"/>
           <a:p xmlns:a="http://schemas.openxmlformats.org/drawingml/2006/main">
-            <a:pPr algn="ctr">
-              <a:buNone/>
-              <a:defRPr sz="1200" b="0">
-                <a:solidFill>
-                  <a:srgbClr val="FFFFFF"/>
-                </a:solidFill>
-                <a:latin typeface="Aptos"/>
-                <a:ea typeface="Aptos"/>
-                <a:cs typeface="Aptos"/>
-              </a:defRPr>
-            </a:pPr>
-            <a:r>
-              <a:t>Autenticação e registro seguro</a:t>
+            <a:r>
+              <a:t>Autenticação, regras e auditoria</a:t>
             </a:r>
           </a:p>
         </p:txBody>
@@ -10402,19 +12979,8 @@
           </a:bodyPr>
           <a:lstStyle xmlns:a="http://schemas.openxmlformats.org/drawingml/2006/main"/>
           <a:p xmlns:a="http://schemas.openxmlformats.org/drawingml/2006/main">
-            <a:pPr algn="ctr">
-              <a:buNone/>
-              <a:defRPr sz="1200" b="0">
-                <a:solidFill>
-                  <a:srgbClr val="FFFFFF"/>
-                </a:solidFill>
-                <a:latin typeface="Aptos"/>
-                <a:ea typeface="Aptos"/>
-                <a:cs typeface="Aptos"/>
-              </a:defRPr>
-            </a:pPr>
-            <a:r>
-              <a:t>Triagem, despacho e conclusão</a:t>
+            <a:r>
+              <a:t>Triagem, status e encerramento</a:t>
             </a:r>
           </a:p>
         </p:txBody>
@@ -12357,19 +14923,8 @@
           </a:bodyPr>
           <a:lstStyle xmlns:a="http://schemas.openxmlformats.org/drawingml/2006/main"/>
           <a:p xmlns:a="http://schemas.openxmlformats.org/drawingml/2006/main">
-            <a:pPr algn="l">
-              <a:buNone/>
-              <a:defRPr sz="2700" b="1">
-                <a:solidFill>
-                  <a:srgbClr val="17233A"/>
-                </a:solidFill>
-                <a:latin typeface="Aptos"/>
-                <a:ea typeface="Aptos"/>
-                <a:cs typeface="Aptos"/>
-              </a:defRPr>
-            </a:pPr>
-            <a:r>
-              <a:t>Cadastro inclusivo e preparado para o contexto</a:t>
+            <a:r>
+              <a:t>Cadastro com identidade verificada e contexto institucional</a:t>
             </a:r>
           </a:p>
         </p:txBody>
@@ -12404,19 +14959,8 @@
           </a:bodyPr>
           <a:lstStyle xmlns:a="http://schemas.openxmlformats.org/drawingml/2006/main"/>
           <a:p xmlns:a="http://schemas.openxmlformats.org/drawingml/2006/main">
-            <a:pPr algn="l">
-              <a:buNone/>
-              <a:defRPr sz="1200" b="0">
-                <a:solidFill>
-                  <a:srgbClr val="60728A"/>
-                </a:solidFill>
-                <a:latin typeface="Aptos"/>
-                <a:ea typeface="Aptos"/>
-                <a:cs typeface="Aptos"/>
-              </a:defRPr>
-            </a:pPr>
-            <a:r>
-              <a:t>A validação foi ampliada para aceitar qualquer e-mail válido — inclusive visitantes em trânsito no campus.</a:t>
+            <a:r>
+              <a:t>O cadastro utiliza e-mail e senha, mas o uso institucional exige confirmação do e-mail e vínculo ativo com a instituição autorizada.</a:t>
             </a:r>
           </a:p>
         </p:txBody>
@@ -12640,19 +15184,8 @@
           </a:bodyPr>
           <a:lstStyle xmlns:a="http://schemas.openxmlformats.org/drawingml/2006/main"/>
           <a:p xmlns:a="http://schemas.openxmlformats.org/drawingml/2006/main">
-            <a:pPr algn="l">
-              <a:buNone/>
-              <a:defRPr sz="1500" b="1">
-                <a:solidFill>
-                  <a:srgbClr val="17233A"/>
-                </a:solidFill>
-                <a:latin typeface="Aptos"/>
-                <a:ea typeface="Aptos"/>
-                <a:cs typeface="Aptos"/>
-              </a:defRPr>
-            </a:pPr>
-            <a:r>
-              <a:t>Acesso mais inclusivo</a:t>
+            <a:r>
+              <a:t>Acesso controlado</a:t>
             </a:r>
           </a:p>
         </p:txBody>
@@ -12687,19 +15220,8 @@
           </a:bodyPr>
           <a:lstStyle xmlns:a="http://schemas.openxmlformats.org/drawingml/2006/main"/>
           <a:p xmlns:a="http://schemas.openxmlformats.org/drawingml/2006/main">
-            <a:pPr algn="l">
-              <a:buNone/>
-              <a:defRPr sz="1100" b="0">
-                <a:solidFill>
-                  <a:srgbClr val="60728A"/>
-                </a:solidFill>
-                <a:latin typeface="Aptos"/>
-                <a:ea typeface="Aptos"/>
-                <a:cs typeface="Aptos"/>
-              </a:defRPr>
-            </a:pPr>
-            <a:r>
-              <a:t>Qualquer pessoa pode iniciar o fluxo sem depender de domínio institucional.</a:t>
+            <a:r>
+              <a:t>A credencial não basta: o usuário precisa ter e-mail verificado e membership institucional ativa.</a:t>
             </a:r>
           </a:p>
         </p:txBody>
@@ -12844,19 +15366,8 @@
           </a:bodyPr>
           <a:lstStyle xmlns:a="http://schemas.openxmlformats.org/drawingml/2006/main"/>
           <a:p xmlns:a="http://schemas.openxmlformats.org/drawingml/2006/main">
-            <a:pPr algn="l">
-              <a:buNone/>
-              <a:defRPr sz="1500" b="1">
-                <a:solidFill>
-                  <a:srgbClr val="17233A"/>
-                </a:solidFill>
-                <a:latin typeface="Aptos"/>
-                <a:ea typeface="Aptos"/>
-                <a:cs typeface="Aptos"/>
-              </a:defRPr>
-            </a:pPr>
-            <a:r>
-              <a:t>Identificação contextual</a:t>
+            <a:r>
+              <a:t>Identificação institucional</a:t>
             </a:r>
           </a:p>
         </p:txBody>
@@ -12891,19 +15402,8 @@
           </a:bodyPr>
           <a:lstStyle xmlns:a="http://schemas.openxmlformats.org/drawingml/2006/main"/>
           <a:p xmlns:a="http://schemas.openxmlformats.org/drawingml/2006/main">
-            <a:pPr algn="l">
-              <a:buNone/>
-              <a:defRPr sz="1100" b="0">
-                <a:solidFill>
-                  <a:srgbClr val="60728A"/>
-                </a:solidFill>
-                <a:latin typeface="Aptos"/>
-                <a:ea typeface="Aptos"/>
-                <a:cs typeface="Aptos"/>
-              </a:defRPr>
-            </a:pPr>
-            <a:r>
-              <a:t>Vínculo, matrícula/CPF, telefone e contato de emergência apoiam a triagem.</a:t>
+            <a:r>
+              <a:t>O institutionId separa usuários, operadores e alertas entre instituições, evitando acesso cruzado.</a:t>
             </a:r>
           </a:p>
         </p:txBody>
@@ -13095,19 +15595,8 @@
           </a:bodyPr>
           <a:lstStyle xmlns:a="http://schemas.openxmlformats.org/drawingml/2006/main"/>
           <a:p xmlns:a="http://schemas.openxmlformats.org/drawingml/2006/main">
-            <a:pPr algn="l">
-              <a:buNone/>
-              <a:defRPr sz="1100" b="0">
-                <a:solidFill>
-                  <a:srgbClr val="60728A"/>
-                </a:solidFill>
-                <a:latin typeface="Aptos"/>
-                <a:ea typeface="Aptos"/>
-                <a:cs typeface="Aptos"/>
-              </a:defRPr>
-            </a:pPr>
-            <a:r>
-              <a:t>Coletar somente o necessário, com consentimento e finalidade explícita.</a:t>
+            <a:r>
+              <a:t>Dados médicos e medicalNotes foram retirados/bloqueados; a coleta permanece limitada ao necessário para a ocorrência.</a:t>
             </a:r>
           </a:p>
         </p:txBody>
@@ -14691,19 +17180,8 @@
           </a:bodyPr>
           <a:lstStyle xmlns:a="http://schemas.openxmlformats.org/drawingml/2006/main"/>
           <a:p xmlns:a="http://schemas.openxmlformats.org/drawingml/2006/main">
-            <a:pPr algn="l">
-              <a:buNone/>
-              <a:defRPr sz="1300" b="0">
-                <a:solidFill>
-                  <a:srgbClr val="FFFFFF"/>
-                </a:solidFill>
-                <a:latin typeface="Aptos"/>
-                <a:ea typeface="Aptos"/>
-                <a:cs typeface="Aptos"/>
-              </a:defRPr>
-            </a:pPr>
-            <a:r>
-              <a:t>Authentication • Firestore</a:t>
+            <a:r>
+              <a:t>Authentication • Firestore • Storage</a:t>
             </a:r>
           </a:p>
         </p:txBody>
@@ -14887,19 +17365,8 @@
           </a:bodyPr>
           <a:lstStyle xmlns:a="http://schemas.openxmlformats.org/drawingml/2006/main"/>
           <a:p xmlns:a="http://schemas.openxmlformats.org/drawingml/2006/main">
-            <a:pPr algn="ctr">
-              <a:buNone/>
-              <a:defRPr sz="1400" b="1">
-                <a:solidFill>
-                  <a:srgbClr val="082F57"/>
-                </a:solidFill>
-                <a:latin typeface="Aptos"/>
-                <a:ea typeface="Aptos"/>
-                <a:cs typeface="Aptos"/>
-              </a:defRPr>
-            </a:pPr>
-            <a:r>
-              <a:t>O mesmo Firestore conecta a experiência do usuário à visão do operador.</a:t>
+            <a:r>
+              <a:t>Firebase conecta usuário e central com regras por institutionId, trilha de auditoria e evidências protegidas.</a:t>
             </a:r>
           </a:p>
         </p:txBody>
@@ -15402,11 +17869,47 @@
           </a:bodyPr>
           <a:lstStyle xmlns:a="http://schemas.openxmlformats.org/drawingml/2006/main"/>
           <a:p xmlns:a="http://schemas.openxmlformats.org/drawingml/2006/main">
+            <a:r>
+              <a:t>Autenticação Firebase por e-mail/senha</a:t>
+            </a:r>
+          </a:p>
+        </p:txBody>
+      </p:sp>
+      <p:sp>
+        <p:nvSpPr>
+          <p:cNvPr id="10" name="TextBox 9">
+            <a:extLst xmlns:a="http://schemas.openxmlformats.org/drawingml/2006/main">
+              <a:ext uri="{FF2B5EF4-FFF2-40B4-BE49-F238E27FC236}">
+                <a16:creationId xmlns:a16="http://schemas.microsoft.com/office/drawing/2014/main" id="{2CDE62F7-14F3-49D6-8463-9ADA9E63786F}"/>
+              </a:ext>
+            </a:extLst>
+          </p:cNvPr>
+          <p:cNvSpPr>
+            <a:spLocks xmlns:a="http://schemas.openxmlformats.org/drawingml/2006/main" noGrp="1"/>
+          </p:cNvSpPr>
+          <p:nvPr/>
+        </p:nvSpPr>
+        <p:spPr>
+          <a:xfrm xmlns:a="http://schemas.openxmlformats.org/drawingml/2006/main">
+            <a:off x="1005840" y="3310128"/>
+            <a:ext cx="320040" cy="228600"/>
+          </a:xfrm>
+          <a:prstGeom xmlns:a="http://schemas.openxmlformats.org/drawingml/2006/main" prst="rect">
+            <a:avLst/>
+          </a:prstGeom>
+          <a:noFill xmlns:a="http://schemas.openxmlformats.org/drawingml/2006/main"/>
+        </p:spPr>
+        <p:txBody>
+          <a:bodyPr xmlns:a="http://schemas.openxmlformats.org/drawingml/2006/main" wrap="square" lIns="45720" rIns="45720">
+            <a:spAutoFit/>
+          </a:bodyPr>
+          <a:lstStyle xmlns:a="http://schemas.openxmlformats.org/drawingml/2006/main"/>
+          <a:p xmlns:a="http://schemas.openxmlformats.org/drawingml/2006/main">
             <a:pPr algn="l">
               <a:buNone/>
-              <a:defRPr sz="1300" b="0">
-                <a:solidFill>
-                  <a:srgbClr val="17233A"/>
+              <a:defRPr sz="1300" b="1">
+                <a:solidFill>
+                  <a:srgbClr val="1FA774"/>
                 </a:solidFill>
                 <a:latin typeface="Aptos"/>
                 <a:ea typeface="Aptos"/>
@@ -15414,28 +17917,64 @@
               </a:defRPr>
             </a:pPr>
             <a:r>
-              <a:t>Autenticação Firebase</a:t>
-            </a:r>
-          </a:p>
-        </p:txBody>
-      </p:sp>
-      <p:sp>
-        <p:nvSpPr>
-          <p:cNvPr id="10" name="TextBox 9">
-            <a:extLst xmlns:a="http://schemas.openxmlformats.org/drawingml/2006/main">
-              <a:ext uri="{FF2B5EF4-FFF2-40B4-BE49-F238E27FC236}">
-                <a16:creationId xmlns:a16="http://schemas.microsoft.com/office/drawing/2014/main" id="{2CDE62F7-14F3-49D6-8463-9ADA9E63786F}"/>
-              </a:ext>
-            </a:extLst>
-          </p:cNvPr>
-          <p:cNvSpPr>
-            <a:spLocks xmlns:a="http://schemas.openxmlformats.org/drawingml/2006/main" noGrp="1"/>
-          </p:cNvSpPr>
-          <p:nvPr/>
-        </p:nvSpPr>
-        <p:spPr>
-          <a:xfrm xmlns:a="http://schemas.openxmlformats.org/drawingml/2006/main">
-            <a:off x="1005840" y="3310128"/>
+              <a:t>✓</a:t>
+            </a:r>
+          </a:p>
+        </p:txBody>
+      </p:sp>
+      <p:sp>
+        <p:nvSpPr>
+          <p:cNvPr id="11" name="TextBox 10">
+            <a:extLst xmlns:a="http://schemas.openxmlformats.org/drawingml/2006/main">
+              <a:ext uri="{FF2B5EF4-FFF2-40B4-BE49-F238E27FC236}">
+                <a16:creationId xmlns:a16="http://schemas.microsoft.com/office/drawing/2014/main" id="{14612845-DF67-4FD4-8D07-3780C5A42E20}"/>
+              </a:ext>
+            </a:extLst>
+          </p:cNvPr>
+          <p:cNvSpPr>
+            <a:spLocks xmlns:a="http://schemas.openxmlformats.org/drawingml/2006/main" noGrp="1"/>
+          </p:cNvSpPr>
+          <p:nvPr/>
+        </p:nvSpPr>
+        <p:spPr>
+          <a:xfrm xmlns:a="http://schemas.openxmlformats.org/drawingml/2006/main">
+            <a:off x="1399032" y="3255263"/>
+            <a:ext cx="4160520" cy="347472"/>
+          </a:xfrm>
+          <a:prstGeom xmlns:a="http://schemas.openxmlformats.org/drawingml/2006/main" prst="rect">
+            <a:avLst/>
+          </a:prstGeom>
+          <a:noFill xmlns:a="http://schemas.openxmlformats.org/drawingml/2006/main"/>
+        </p:spPr>
+        <p:txBody>
+          <a:bodyPr xmlns:a="http://schemas.openxmlformats.org/drawingml/2006/main" wrap="square" lIns="45720" rIns="45720">
+            <a:spAutoFit/>
+          </a:bodyPr>
+          <a:lstStyle xmlns:a="http://schemas.openxmlformats.org/drawingml/2006/main"/>
+          <a:p xmlns:a="http://schemas.openxmlformats.org/drawingml/2006/main">
+            <a:r>
+              <a:t>E-mail verificado + vínculo institucional ativo</a:t>
+            </a:r>
+          </a:p>
+        </p:txBody>
+      </p:sp>
+      <p:sp>
+        <p:nvSpPr>
+          <p:cNvPr id="12" name="TextBox 11">
+            <a:extLst xmlns:a="http://schemas.openxmlformats.org/drawingml/2006/main">
+              <a:ext uri="{FF2B5EF4-FFF2-40B4-BE49-F238E27FC236}">
+                <a16:creationId xmlns:a16="http://schemas.microsoft.com/office/drawing/2014/main" id="{863A74D3-F973-41CC-8B83-87A0646D5783}"/>
+              </a:ext>
+            </a:extLst>
+          </p:cNvPr>
+          <p:cNvSpPr>
+            <a:spLocks xmlns:a="http://schemas.openxmlformats.org/drawingml/2006/main" noGrp="1"/>
+          </p:cNvSpPr>
+          <p:nvPr/>
+        </p:nvSpPr>
+        <p:spPr>
+          <a:xfrm xmlns:a="http://schemas.openxmlformats.org/drawingml/2006/main">
+            <a:off x="1005840" y="3968496"/>
             <a:ext cx="320040" cy="228600"/>
           </a:xfrm>
           <a:prstGeom xmlns:a="http://schemas.openxmlformats.org/drawingml/2006/main" prst="rect">
@@ -15468,21 +18007,21 @@
       </p:sp>
       <p:sp>
         <p:nvSpPr>
-          <p:cNvPr id="11" name="TextBox 10">
-            <a:extLst xmlns:a="http://schemas.openxmlformats.org/drawingml/2006/main">
-              <a:ext uri="{FF2B5EF4-FFF2-40B4-BE49-F238E27FC236}">
-                <a16:creationId xmlns:a16="http://schemas.microsoft.com/office/drawing/2014/main" id="{14612845-DF67-4FD4-8D07-3780C5A42E20}"/>
-              </a:ext>
-            </a:extLst>
-          </p:cNvPr>
-          <p:cNvSpPr>
-            <a:spLocks xmlns:a="http://schemas.openxmlformats.org/drawingml/2006/main" noGrp="1"/>
-          </p:cNvSpPr>
-          <p:nvPr/>
-        </p:nvSpPr>
-        <p:spPr>
-          <a:xfrm xmlns:a="http://schemas.openxmlformats.org/drawingml/2006/main">
-            <a:off x="1399032" y="3255263"/>
+          <p:cNvPr id="13" name="TextBox 12">
+            <a:extLst xmlns:a="http://schemas.openxmlformats.org/drawingml/2006/main">
+              <a:ext uri="{FF2B5EF4-FFF2-40B4-BE49-F238E27FC236}">
+                <a16:creationId xmlns:a16="http://schemas.microsoft.com/office/drawing/2014/main" id="{00F0540C-D39C-429D-AFF9-C0EBF8720CB6}"/>
+              </a:ext>
+            </a:extLst>
+          </p:cNvPr>
+          <p:cNvSpPr>
+            <a:spLocks xmlns:a="http://schemas.openxmlformats.org/drawingml/2006/main" noGrp="1"/>
+          </p:cNvSpPr>
+          <p:nvPr/>
+        </p:nvSpPr>
+        <p:spPr>
+          <a:xfrm xmlns:a="http://schemas.openxmlformats.org/drawingml/2006/main">
+            <a:off x="1399032" y="3913631"/>
             <a:ext cx="4160520" cy="347472"/>
           </a:xfrm>
           <a:prstGeom xmlns:a="http://schemas.openxmlformats.org/drawingml/2006/main" prst="rect">
@@ -15496,11 +18035,47 @@
           </a:bodyPr>
           <a:lstStyle xmlns:a="http://schemas.openxmlformats.org/drawingml/2006/main"/>
           <a:p xmlns:a="http://schemas.openxmlformats.org/drawingml/2006/main">
+            <a:r>
+              <a:t>Isolamento por institutionId e perfis separados</a:t>
+            </a:r>
+          </a:p>
+        </p:txBody>
+      </p:sp>
+      <p:sp>
+        <p:nvSpPr>
+          <p:cNvPr id="14" name="TextBox 13">
+            <a:extLst xmlns:a="http://schemas.openxmlformats.org/drawingml/2006/main">
+              <a:ext uri="{FF2B5EF4-FFF2-40B4-BE49-F238E27FC236}">
+                <a16:creationId xmlns:a16="http://schemas.microsoft.com/office/drawing/2014/main" id="{E452DF92-3919-4620-A779-26779647C258}"/>
+              </a:ext>
+            </a:extLst>
+          </p:cNvPr>
+          <p:cNvSpPr>
+            <a:spLocks xmlns:a="http://schemas.openxmlformats.org/drawingml/2006/main" noGrp="1"/>
+          </p:cNvSpPr>
+          <p:nvPr/>
+        </p:nvSpPr>
+        <p:spPr>
+          <a:xfrm xmlns:a="http://schemas.openxmlformats.org/drawingml/2006/main">
+            <a:off x="1005840" y="4626864"/>
+            <a:ext cx="320040" cy="228600"/>
+          </a:xfrm>
+          <a:prstGeom xmlns:a="http://schemas.openxmlformats.org/drawingml/2006/main" prst="rect">
+            <a:avLst/>
+          </a:prstGeom>
+          <a:noFill xmlns:a="http://schemas.openxmlformats.org/drawingml/2006/main"/>
+        </p:spPr>
+        <p:txBody>
+          <a:bodyPr xmlns:a="http://schemas.openxmlformats.org/drawingml/2006/main" wrap="square" lIns="45720" rIns="45720">
+            <a:spAutoFit/>
+          </a:bodyPr>
+          <a:lstStyle xmlns:a="http://schemas.openxmlformats.org/drawingml/2006/main"/>
+          <a:p xmlns:a="http://schemas.openxmlformats.org/drawingml/2006/main">
             <a:pPr algn="l">
               <a:buNone/>
-              <a:defRPr sz="1300" b="0">
-                <a:solidFill>
-                  <a:srgbClr val="17233A"/>
+              <a:defRPr sz="1300" b="1">
+                <a:solidFill>
+                  <a:srgbClr val="1FA774"/>
                 </a:solidFill>
                 <a:latin typeface="Aptos"/>
                 <a:ea typeface="Aptos"/>
@@ -15508,147 +18083,6 @@
               </a:defRPr>
             </a:pPr>
             <a:r>
-              <a:t>Regras de acesso no Firestore</a:t>
-            </a:r>
-          </a:p>
-        </p:txBody>
-      </p:sp>
-      <p:sp>
-        <p:nvSpPr>
-          <p:cNvPr id="12" name="TextBox 11">
-            <a:extLst xmlns:a="http://schemas.openxmlformats.org/drawingml/2006/main">
-              <a:ext uri="{FF2B5EF4-FFF2-40B4-BE49-F238E27FC236}">
-                <a16:creationId xmlns:a16="http://schemas.microsoft.com/office/drawing/2014/main" id="{863A74D3-F973-41CC-8B83-87A0646D5783}"/>
-              </a:ext>
-            </a:extLst>
-          </p:cNvPr>
-          <p:cNvSpPr>
-            <a:spLocks xmlns:a="http://schemas.openxmlformats.org/drawingml/2006/main" noGrp="1"/>
-          </p:cNvSpPr>
-          <p:nvPr/>
-        </p:nvSpPr>
-        <p:spPr>
-          <a:xfrm xmlns:a="http://schemas.openxmlformats.org/drawingml/2006/main">
-            <a:off x="1005840" y="3968496"/>
-            <a:ext cx="320040" cy="228600"/>
-          </a:xfrm>
-          <a:prstGeom xmlns:a="http://schemas.openxmlformats.org/drawingml/2006/main" prst="rect">
-            <a:avLst/>
-          </a:prstGeom>
-          <a:noFill xmlns:a="http://schemas.openxmlformats.org/drawingml/2006/main"/>
-        </p:spPr>
-        <p:txBody>
-          <a:bodyPr xmlns:a="http://schemas.openxmlformats.org/drawingml/2006/main" wrap="square" lIns="45720" rIns="45720">
-            <a:spAutoFit/>
-          </a:bodyPr>
-          <a:lstStyle xmlns:a="http://schemas.openxmlformats.org/drawingml/2006/main"/>
-          <a:p xmlns:a="http://schemas.openxmlformats.org/drawingml/2006/main">
-            <a:pPr algn="l">
-              <a:buNone/>
-              <a:defRPr sz="1300" b="1">
-                <a:solidFill>
-                  <a:srgbClr val="1FA774"/>
-                </a:solidFill>
-                <a:latin typeface="Aptos"/>
-                <a:ea typeface="Aptos"/>
-                <a:cs typeface="Aptos"/>
-              </a:defRPr>
-            </a:pPr>
-            <a:r>
-              <a:t>✓</a:t>
-            </a:r>
-          </a:p>
-        </p:txBody>
-      </p:sp>
-      <p:sp>
-        <p:nvSpPr>
-          <p:cNvPr id="13" name="TextBox 12">
-            <a:extLst xmlns:a="http://schemas.openxmlformats.org/drawingml/2006/main">
-              <a:ext uri="{FF2B5EF4-FFF2-40B4-BE49-F238E27FC236}">
-                <a16:creationId xmlns:a16="http://schemas.microsoft.com/office/drawing/2014/main" id="{00F0540C-D39C-429D-AFF9-C0EBF8720CB6}"/>
-              </a:ext>
-            </a:extLst>
-          </p:cNvPr>
-          <p:cNvSpPr>
-            <a:spLocks xmlns:a="http://schemas.openxmlformats.org/drawingml/2006/main" noGrp="1"/>
-          </p:cNvSpPr>
-          <p:nvPr/>
-        </p:nvSpPr>
-        <p:spPr>
-          <a:xfrm xmlns:a="http://schemas.openxmlformats.org/drawingml/2006/main">
-            <a:off x="1399032" y="3913631"/>
-            <a:ext cx="4160520" cy="347472"/>
-          </a:xfrm>
-          <a:prstGeom xmlns:a="http://schemas.openxmlformats.org/drawingml/2006/main" prst="rect">
-            <a:avLst/>
-          </a:prstGeom>
-          <a:noFill xmlns:a="http://schemas.openxmlformats.org/drawingml/2006/main"/>
-        </p:spPr>
-        <p:txBody>
-          <a:bodyPr xmlns:a="http://schemas.openxmlformats.org/drawingml/2006/main" wrap="square" lIns="45720" rIns="45720">
-            <a:spAutoFit/>
-          </a:bodyPr>
-          <a:lstStyle xmlns:a="http://schemas.openxmlformats.org/drawingml/2006/main"/>
-          <a:p xmlns:a="http://schemas.openxmlformats.org/drawingml/2006/main">
-            <a:pPr algn="l">
-              <a:buNone/>
-              <a:defRPr sz="1300" b="0">
-                <a:solidFill>
-                  <a:srgbClr val="17233A"/>
-                </a:solidFill>
-                <a:latin typeface="Aptos"/>
-                <a:ea typeface="Aptos"/>
-                <a:cs typeface="Aptos"/>
-              </a:defRPr>
-            </a:pPr>
-            <a:r>
-              <a:t>Perfis separados: usuário e operador</a:t>
-            </a:r>
-          </a:p>
-        </p:txBody>
-      </p:sp>
-      <p:sp>
-        <p:nvSpPr>
-          <p:cNvPr id="14" name="TextBox 13">
-            <a:extLst xmlns:a="http://schemas.openxmlformats.org/drawingml/2006/main">
-              <a:ext uri="{FF2B5EF4-FFF2-40B4-BE49-F238E27FC236}">
-                <a16:creationId xmlns:a16="http://schemas.microsoft.com/office/drawing/2014/main" id="{E452DF92-3919-4620-A779-26779647C258}"/>
-              </a:ext>
-            </a:extLst>
-          </p:cNvPr>
-          <p:cNvSpPr>
-            <a:spLocks xmlns:a="http://schemas.openxmlformats.org/drawingml/2006/main" noGrp="1"/>
-          </p:cNvSpPr>
-          <p:nvPr/>
-        </p:nvSpPr>
-        <p:spPr>
-          <a:xfrm xmlns:a="http://schemas.openxmlformats.org/drawingml/2006/main">
-            <a:off x="1005840" y="4626864"/>
-            <a:ext cx="320040" cy="228600"/>
-          </a:xfrm>
-          <a:prstGeom xmlns:a="http://schemas.openxmlformats.org/drawingml/2006/main" prst="rect">
-            <a:avLst/>
-          </a:prstGeom>
-          <a:noFill xmlns:a="http://schemas.openxmlformats.org/drawingml/2006/main"/>
-        </p:spPr>
-        <p:txBody>
-          <a:bodyPr xmlns:a="http://schemas.openxmlformats.org/drawingml/2006/main" wrap="square" lIns="45720" rIns="45720">
-            <a:spAutoFit/>
-          </a:bodyPr>
-          <a:lstStyle xmlns:a="http://schemas.openxmlformats.org/drawingml/2006/main"/>
-          <a:p xmlns:a="http://schemas.openxmlformats.org/drawingml/2006/main">
-            <a:pPr algn="l">
-              <a:buNone/>
-              <a:defRPr sz="1300" b="1">
-                <a:solidFill>
-                  <a:srgbClr val="1FA774"/>
-                </a:solidFill>
-                <a:latin typeface="Aptos"/>
-                <a:ea typeface="Aptos"/>
-                <a:cs typeface="Aptos"/>
-              </a:defRPr>
-            </a:pPr>
-            <a:r>
               <a:t>✓</a:t>
             </a:r>
           </a:p>
@@ -15684,19 +18118,8 @@
           </a:bodyPr>
           <a:lstStyle xmlns:a="http://schemas.openxmlformats.org/drawingml/2006/main"/>
           <a:p xmlns:a="http://schemas.openxmlformats.org/drawingml/2006/main">
-            <a:pPr algn="l">
-              <a:buNone/>
-              <a:defRPr sz="1300" b="0">
-                <a:solidFill>
-                  <a:srgbClr val="17233A"/>
-                </a:solidFill>
-                <a:latin typeface="Aptos"/>
-                <a:ea typeface="Aptos"/>
-                <a:cs typeface="Aptos"/>
-              </a:defRPr>
-            </a:pPr>
-            <a:r>
-              <a:t>Bloqueio de exclusão de alertas</a:t>
+            <a:r>
+              <a:t>Auditoria append-only + evidências sem sobrescrita</a:t>
             </a:r>
           </a:p>
         </p:txBody>
@@ -15935,11 +18358,47 @@
           </a:bodyPr>
           <a:lstStyle xmlns:a="http://schemas.openxmlformats.org/drawingml/2006/main"/>
           <a:p xmlns:a="http://schemas.openxmlformats.org/drawingml/2006/main">
+            <a:r>
+              <a:t>Ativar TTL remoto no Firestore</a:t>
+            </a:r>
+          </a:p>
+        </p:txBody>
+      </p:sp>
+      <p:sp>
+        <p:nvSpPr>
+          <p:cNvPr id="21" name="TextBox 20">
+            <a:extLst xmlns:a="http://schemas.openxmlformats.org/drawingml/2006/main">
+              <a:ext uri="{FF2B5EF4-FFF2-40B4-BE49-F238E27FC236}">
+                <a16:creationId xmlns:a16="http://schemas.microsoft.com/office/drawing/2014/main" id="{DB421564-B6F3-40A5-9B8E-2487BFDB8C25}"/>
+              </a:ext>
+            </a:extLst>
+          </p:cNvPr>
+          <p:cNvSpPr>
+            <a:spLocks xmlns:a="http://schemas.openxmlformats.org/drawingml/2006/main" noGrp="1"/>
+          </p:cNvSpPr>
+          <p:nvPr/>
+        </p:nvSpPr>
+        <p:spPr>
+          <a:xfrm xmlns:a="http://schemas.openxmlformats.org/drawingml/2006/main">
+            <a:off x="6629400" y="3310128"/>
+            <a:ext cx="320040" cy="228600"/>
+          </a:xfrm>
+          <a:prstGeom xmlns:a="http://schemas.openxmlformats.org/drawingml/2006/main" prst="rect">
+            <a:avLst/>
+          </a:prstGeom>
+          <a:noFill xmlns:a="http://schemas.openxmlformats.org/drawingml/2006/main"/>
+        </p:spPr>
+        <p:txBody>
+          <a:bodyPr xmlns:a="http://schemas.openxmlformats.org/drawingml/2006/main" wrap="square" lIns="45720" rIns="45720">
+            <a:spAutoFit/>
+          </a:bodyPr>
+          <a:lstStyle xmlns:a="http://schemas.openxmlformats.org/drawingml/2006/main"/>
+          <a:p xmlns:a="http://schemas.openxmlformats.org/drawingml/2006/main">
             <a:pPr algn="l">
               <a:buNone/>
-              <a:defRPr sz="1300" b="0">
-                <a:solidFill>
-                  <a:srgbClr val="17233A"/>
+              <a:defRPr sz="1300" b="1">
+                <a:solidFill>
+                  <a:srgbClr val="F2B134"/>
                 </a:solidFill>
                 <a:latin typeface="Aptos"/>
                 <a:ea typeface="Aptos"/>
@@ -15947,28 +18406,64 @@
               </a:defRPr>
             </a:pPr>
             <a:r>
-              <a:t>Verificação de propriedade do e-mail</a:t>
-            </a:r>
-          </a:p>
-        </p:txBody>
-      </p:sp>
-      <p:sp>
-        <p:nvSpPr>
-          <p:cNvPr id="21" name="TextBox 20">
-            <a:extLst xmlns:a="http://schemas.openxmlformats.org/drawingml/2006/main">
-              <a:ext uri="{FF2B5EF4-FFF2-40B4-BE49-F238E27FC236}">
-                <a16:creationId xmlns:a16="http://schemas.microsoft.com/office/drawing/2014/main" id="{DB421564-B6F3-40A5-9B8E-2487BFDB8C25}"/>
-              </a:ext>
-            </a:extLst>
-          </p:cNvPr>
-          <p:cNvSpPr>
-            <a:spLocks xmlns:a="http://schemas.openxmlformats.org/drawingml/2006/main" noGrp="1"/>
-          </p:cNvSpPr>
-          <p:nvPr/>
-        </p:nvSpPr>
-        <p:spPr>
-          <a:xfrm xmlns:a="http://schemas.openxmlformats.org/drawingml/2006/main">
-            <a:off x="6629400" y="3310128"/>
+              <a:t>○</a:t>
+            </a:r>
+          </a:p>
+        </p:txBody>
+      </p:sp>
+      <p:sp>
+        <p:nvSpPr>
+          <p:cNvPr id="22" name="TextBox 21">
+            <a:extLst xmlns:a="http://schemas.openxmlformats.org/drawingml/2006/main">
+              <a:ext uri="{FF2B5EF4-FFF2-40B4-BE49-F238E27FC236}">
+                <a16:creationId xmlns:a16="http://schemas.microsoft.com/office/drawing/2014/main" id="{4719BA04-DF85-4173-A9E9-2511E51E61D3}"/>
+              </a:ext>
+            </a:extLst>
+          </p:cNvPr>
+          <p:cNvSpPr>
+            <a:spLocks xmlns:a="http://schemas.openxmlformats.org/drawingml/2006/main" noGrp="1"/>
+          </p:cNvSpPr>
+          <p:nvPr/>
+        </p:nvSpPr>
+        <p:spPr>
+          <a:xfrm xmlns:a="http://schemas.openxmlformats.org/drawingml/2006/main">
+            <a:off x="7022592" y="3255263"/>
+            <a:ext cx="4160520" cy="347472"/>
+          </a:xfrm>
+          <a:prstGeom xmlns:a="http://schemas.openxmlformats.org/drawingml/2006/main" prst="rect">
+            <a:avLst/>
+          </a:prstGeom>
+          <a:noFill xmlns:a="http://schemas.openxmlformats.org/drawingml/2006/main"/>
+        </p:spPr>
+        <p:txBody>
+          <a:bodyPr xmlns:a="http://schemas.openxmlformats.org/drawingml/2006/main" wrap="square" lIns="45720" rIns="45720">
+            <a:spAutoFit/>
+          </a:bodyPr>
+          <a:lstStyle xmlns:a="http://schemas.openxmlformats.org/drawingml/2006/main"/>
+          <a:p xmlns:a="http://schemas.openxmlformats.org/drawingml/2006/main">
+            <a:r>
+              <a:t>Configurar ciclo de vida do Storage</a:t>
+            </a:r>
+          </a:p>
+        </p:txBody>
+      </p:sp>
+      <p:sp>
+        <p:nvSpPr>
+          <p:cNvPr id="23" name="TextBox 22">
+            <a:extLst xmlns:a="http://schemas.openxmlformats.org/drawingml/2006/main">
+              <a:ext uri="{FF2B5EF4-FFF2-40B4-BE49-F238E27FC236}">
+                <a16:creationId xmlns:a16="http://schemas.microsoft.com/office/drawing/2014/main" id="{73DA0A92-E0BB-479C-87DE-AD4076B93289}"/>
+              </a:ext>
+            </a:extLst>
+          </p:cNvPr>
+          <p:cNvSpPr>
+            <a:spLocks xmlns:a="http://schemas.openxmlformats.org/drawingml/2006/main" noGrp="1"/>
+          </p:cNvSpPr>
+          <p:nvPr/>
+        </p:nvSpPr>
+        <p:spPr>
+          <a:xfrm xmlns:a="http://schemas.openxmlformats.org/drawingml/2006/main">
+            <a:off x="6629400" y="3968496"/>
             <a:ext cx="320040" cy="228600"/>
           </a:xfrm>
           <a:prstGeom xmlns:a="http://schemas.openxmlformats.org/drawingml/2006/main" prst="rect">
@@ -16001,21 +18496,21 @@
       </p:sp>
       <p:sp>
         <p:nvSpPr>
-          <p:cNvPr id="22" name="TextBox 21">
-            <a:extLst xmlns:a="http://schemas.openxmlformats.org/drawingml/2006/main">
-              <a:ext uri="{FF2B5EF4-FFF2-40B4-BE49-F238E27FC236}">
-                <a16:creationId xmlns:a16="http://schemas.microsoft.com/office/drawing/2014/main" id="{4719BA04-DF85-4173-A9E9-2511E51E61D3}"/>
-              </a:ext>
-            </a:extLst>
-          </p:cNvPr>
-          <p:cNvSpPr>
-            <a:spLocks xmlns:a="http://schemas.openxmlformats.org/drawingml/2006/main" noGrp="1"/>
-          </p:cNvSpPr>
-          <p:nvPr/>
-        </p:nvSpPr>
-        <p:spPr>
-          <a:xfrm xmlns:a="http://schemas.openxmlformats.org/drawingml/2006/main">
-            <a:off x="7022592" y="3255263"/>
+          <p:cNvPr id="24" name="TextBox 23">
+            <a:extLst xmlns:a="http://schemas.openxmlformats.org/drawingml/2006/main">
+              <a:ext uri="{FF2B5EF4-FFF2-40B4-BE49-F238E27FC236}">
+                <a16:creationId xmlns:a16="http://schemas.microsoft.com/office/drawing/2014/main" id="{B0DE1C8E-6564-4846-875E-D853B52BA852}"/>
+              </a:ext>
+            </a:extLst>
+          </p:cNvPr>
+          <p:cNvSpPr>
+            <a:spLocks xmlns:a="http://schemas.openxmlformats.org/drawingml/2006/main" noGrp="1"/>
+          </p:cNvSpPr>
+          <p:nvPr/>
+        </p:nvSpPr>
+        <p:spPr>
+          <a:xfrm xmlns:a="http://schemas.openxmlformats.org/drawingml/2006/main">
+            <a:off x="7022592" y="3913631"/>
             <a:ext cx="4160520" cy="347472"/>
           </a:xfrm>
           <a:prstGeom xmlns:a="http://schemas.openxmlformats.org/drawingml/2006/main" prst="rect">
@@ -16029,11 +18524,47 @@
           </a:bodyPr>
           <a:lstStyle xmlns:a="http://schemas.openxmlformats.org/drawingml/2006/main"/>
           <a:p xmlns:a="http://schemas.openxmlformats.org/drawingml/2006/main">
+            <a:r>
+              <a:t>Habilitar App Check e rate limit confiável</a:t>
+            </a:r>
+          </a:p>
+        </p:txBody>
+      </p:sp>
+      <p:sp>
+        <p:nvSpPr>
+          <p:cNvPr id="25" name="TextBox 24">
+            <a:extLst xmlns:a="http://schemas.openxmlformats.org/drawingml/2006/main">
+              <a:ext uri="{FF2B5EF4-FFF2-40B4-BE49-F238E27FC236}">
+                <a16:creationId xmlns:a16="http://schemas.microsoft.com/office/drawing/2014/main" id="{A09A2E6C-D25D-40D3-BB84-BBEA45FEBDFE}"/>
+              </a:ext>
+            </a:extLst>
+          </p:cNvPr>
+          <p:cNvSpPr>
+            <a:spLocks xmlns:a="http://schemas.openxmlformats.org/drawingml/2006/main" noGrp="1"/>
+          </p:cNvSpPr>
+          <p:nvPr/>
+        </p:nvSpPr>
+        <p:spPr>
+          <a:xfrm xmlns:a="http://schemas.openxmlformats.org/drawingml/2006/main">
+            <a:off x="6629400" y="4626864"/>
+            <a:ext cx="320040" cy="228600"/>
+          </a:xfrm>
+          <a:prstGeom xmlns:a="http://schemas.openxmlformats.org/drawingml/2006/main" prst="rect">
+            <a:avLst/>
+          </a:prstGeom>
+          <a:noFill xmlns:a="http://schemas.openxmlformats.org/drawingml/2006/main"/>
+        </p:spPr>
+        <p:txBody>
+          <a:bodyPr xmlns:a="http://schemas.openxmlformats.org/drawingml/2006/main" wrap="square" lIns="45720" rIns="45720">
+            <a:spAutoFit/>
+          </a:bodyPr>
+          <a:lstStyle xmlns:a="http://schemas.openxmlformats.org/drawingml/2006/main"/>
+          <a:p xmlns:a="http://schemas.openxmlformats.org/drawingml/2006/main">
             <a:pPr algn="l">
               <a:buNone/>
-              <a:defRPr sz="1300" b="0">
-                <a:solidFill>
-                  <a:srgbClr val="17233A"/>
+              <a:defRPr sz="1300" b="1">
+                <a:solidFill>
+                  <a:srgbClr val="F2B134"/>
                 </a:solidFill>
                 <a:latin typeface="Aptos"/>
                 <a:ea typeface="Aptos"/>
@@ -16041,147 +18572,6 @@
               </a:defRPr>
             </a:pPr>
             <a:r>
-              <a:t>Política de privacidade e consentimento</a:t>
-            </a:r>
-          </a:p>
-        </p:txBody>
-      </p:sp>
-      <p:sp>
-        <p:nvSpPr>
-          <p:cNvPr id="23" name="TextBox 22">
-            <a:extLst xmlns:a="http://schemas.openxmlformats.org/drawingml/2006/main">
-              <a:ext uri="{FF2B5EF4-FFF2-40B4-BE49-F238E27FC236}">
-                <a16:creationId xmlns:a16="http://schemas.microsoft.com/office/drawing/2014/main" id="{73DA0A92-E0BB-479C-87DE-AD4076B93289}"/>
-              </a:ext>
-            </a:extLst>
-          </p:cNvPr>
-          <p:cNvSpPr>
-            <a:spLocks xmlns:a="http://schemas.openxmlformats.org/drawingml/2006/main" noGrp="1"/>
-          </p:cNvSpPr>
-          <p:nvPr/>
-        </p:nvSpPr>
-        <p:spPr>
-          <a:xfrm xmlns:a="http://schemas.openxmlformats.org/drawingml/2006/main">
-            <a:off x="6629400" y="3968496"/>
-            <a:ext cx="320040" cy="228600"/>
-          </a:xfrm>
-          <a:prstGeom xmlns:a="http://schemas.openxmlformats.org/drawingml/2006/main" prst="rect">
-            <a:avLst/>
-          </a:prstGeom>
-          <a:noFill xmlns:a="http://schemas.openxmlformats.org/drawingml/2006/main"/>
-        </p:spPr>
-        <p:txBody>
-          <a:bodyPr xmlns:a="http://schemas.openxmlformats.org/drawingml/2006/main" wrap="square" lIns="45720" rIns="45720">
-            <a:spAutoFit/>
-          </a:bodyPr>
-          <a:lstStyle xmlns:a="http://schemas.openxmlformats.org/drawingml/2006/main"/>
-          <a:p xmlns:a="http://schemas.openxmlformats.org/drawingml/2006/main">
-            <a:pPr algn="l">
-              <a:buNone/>
-              <a:defRPr sz="1300" b="1">
-                <a:solidFill>
-                  <a:srgbClr val="F2B134"/>
-                </a:solidFill>
-                <a:latin typeface="Aptos"/>
-                <a:ea typeface="Aptos"/>
-                <a:cs typeface="Aptos"/>
-              </a:defRPr>
-            </a:pPr>
-            <a:r>
-              <a:t>○</a:t>
-            </a:r>
-          </a:p>
-        </p:txBody>
-      </p:sp>
-      <p:sp>
-        <p:nvSpPr>
-          <p:cNvPr id="24" name="TextBox 23">
-            <a:extLst xmlns:a="http://schemas.openxmlformats.org/drawingml/2006/main">
-              <a:ext uri="{FF2B5EF4-FFF2-40B4-BE49-F238E27FC236}">
-                <a16:creationId xmlns:a16="http://schemas.microsoft.com/office/drawing/2014/main" id="{B0DE1C8E-6564-4846-875E-D853B52BA852}"/>
-              </a:ext>
-            </a:extLst>
-          </p:cNvPr>
-          <p:cNvSpPr>
-            <a:spLocks xmlns:a="http://schemas.openxmlformats.org/drawingml/2006/main" noGrp="1"/>
-          </p:cNvSpPr>
-          <p:nvPr/>
-        </p:nvSpPr>
-        <p:spPr>
-          <a:xfrm xmlns:a="http://schemas.openxmlformats.org/drawingml/2006/main">
-            <a:off x="7022592" y="3913631"/>
-            <a:ext cx="4160520" cy="347472"/>
-          </a:xfrm>
-          <a:prstGeom xmlns:a="http://schemas.openxmlformats.org/drawingml/2006/main" prst="rect">
-            <a:avLst/>
-          </a:prstGeom>
-          <a:noFill xmlns:a="http://schemas.openxmlformats.org/drawingml/2006/main"/>
-        </p:spPr>
-        <p:txBody>
-          <a:bodyPr xmlns:a="http://schemas.openxmlformats.org/drawingml/2006/main" wrap="square" lIns="45720" rIns="45720">
-            <a:spAutoFit/>
-          </a:bodyPr>
-          <a:lstStyle xmlns:a="http://schemas.openxmlformats.org/drawingml/2006/main"/>
-          <a:p xmlns:a="http://schemas.openxmlformats.org/drawingml/2006/main">
-            <a:pPr algn="l">
-              <a:buNone/>
-              <a:defRPr sz="1300" b="0">
-                <a:solidFill>
-                  <a:srgbClr val="17233A"/>
-                </a:solidFill>
-                <a:latin typeface="Aptos"/>
-                <a:ea typeface="Aptos"/>
-                <a:cs typeface="Aptos"/>
-              </a:defRPr>
-            </a:pPr>
-            <a:r>
-              <a:t>Retenção e anonimização de dados</a:t>
-            </a:r>
-          </a:p>
-        </p:txBody>
-      </p:sp>
-      <p:sp>
-        <p:nvSpPr>
-          <p:cNvPr id="25" name="TextBox 24">
-            <a:extLst xmlns:a="http://schemas.openxmlformats.org/drawingml/2006/main">
-              <a:ext uri="{FF2B5EF4-FFF2-40B4-BE49-F238E27FC236}">
-                <a16:creationId xmlns:a16="http://schemas.microsoft.com/office/drawing/2014/main" id="{A09A2E6C-D25D-40D3-BB84-BBEA45FEBDFE}"/>
-              </a:ext>
-            </a:extLst>
-          </p:cNvPr>
-          <p:cNvSpPr>
-            <a:spLocks xmlns:a="http://schemas.openxmlformats.org/drawingml/2006/main" noGrp="1"/>
-          </p:cNvSpPr>
-          <p:nvPr/>
-        </p:nvSpPr>
-        <p:spPr>
-          <a:xfrm xmlns:a="http://schemas.openxmlformats.org/drawingml/2006/main">
-            <a:off x="6629400" y="4626864"/>
-            <a:ext cx="320040" cy="228600"/>
-          </a:xfrm>
-          <a:prstGeom xmlns:a="http://schemas.openxmlformats.org/drawingml/2006/main" prst="rect">
-            <a:avLst/>
-          </a:prstGeom>
-          <a:noFill xmlns:a="http://schemas.openxmlformats.org/drawingml/2006/main"/>
-        </p:spPr>
-        <p:txBody>
-          <a:bodyPr xmlns:a="http://schemas.openxmlformats.org/drawingml/2006/main" wrap="square" lIns="45720" rIns="45720">
-            <a:spAutoFit/>
-          </a:bodyPr>
-          <a:lstStyle xmlns:a="http://schemas.openxmlformats.org/drawingml/2006/main"/>
-          <a:p xmlns:a="http://schemas.openxmlformats.org/drawingml/2006/main">
-            <a:pPr algn="l">
-              <a:buNone/>
-              <a:defRPr sz="1300" b="1">
-                <a:solidFill>
-                  <a:srgbClr val="F2B134"/>
-                </a:solidFill>
-                <a:latin typeface="Aptos"/>
-                <a:ea typeface="Aptos"/>
-                <a:cs typeface="Aptos"/>
-              </a:defRPr>
-            </a:pPr>
-            <a:r>
               <a:t>○</a:t>
             </a:r>
           </a:p>
@@ -16217,19 +18607,8 @@
           </a:bodyPr>
           <a:lstStyle xmlns:a="http://schemas.openxmlformats.org/drawingml/2006/main"/>
           <a:p xmlns:a="http://schemas.openxmlformats.org/drawingml/2006/main">
-            <a:pPr algn="l">
-              <a:buNone/>
-              <a:defRPr sz="1300" b="0">
-                <a:solidFill>
-                  <a:srgbClr val="17233A"/>
-                </a:solidFill>
-                <a:latin typeface="Aptos"/>
-                <a:ea typeface="Aptos"/>
-                <a:cs typeface="Aptos"/>
-              </a:defRPr>
-            </a:pPr>
-            <a:r>
-              <a:t>App Check, logs e auditoria institucional</a:t>
+            <a:r>
+              <a:t>Validar fluxo ponta a ponta e testes negativos</a:t>
             </a:r>
           </a:p>
         </p:txBody>
@@ -16434,19 +18813,8 @@
           </a:bodyPr>
           <a:lstStyle xmlns:a="http://schemas.openxmlformats.org/drawingml/2006/main"/>
           <a:p xmlns:a="http://schemas.openxmlformats.org/drawingml/2006/main">
-            <a:pPr algn="l">
-              <a:buNone/>
-              <a:defRPr sz="2700" b="1">
-                <a:solidFill>
-                  <a:srgbClr val="17233A"/>
-                </a:solidFill>
-                <a:latin typeface="Aptos"/>
-                <a:ea typeface="Aptos"/>
-                <a:cs typeface="Aptos"/>
-              </a:defRPr>
-            </a:pPr>
-            <a:r>
-              <a:t>Validação técnica do fluxo principal</a:t>
+            <a:r>
+              <a:t>Validação técnica e pontos ainda pendentes</a:t>
             </a:r>
           </a:p>
         </p:txBody>
@@ -16481,19 +18849,8 @@
           </a:bodyPr>
           <a:lstStyle xmlns:a="http://schemas.openxmlformats.org/drawingml/2006/main"/>
           <a:p xmlns:a="http://schemas.openxmlformats.org/drawingml/2006/main">
-            <a:pPr algn="l">
-              <a:buNone/>
-              <a:defRPr sz="1200" b="0">
-                <a:solidFill>
-                  <a:srgbClr val="60728A"/>
-                </a:solidFill>
-                <a:latin typeface="Aptos"/>
-                <a:ea typeface="Aptos"/>
-                <a:cs typeface="Aptos"/>
-              </a:defRPr>
-            </a:pPr>
-            <a:r>
-              <a:t>Testes realizados no ambiente de desenvolvimento e na implantação demonstrativa.</a:t>
+            <a:r>
+              <a:t>O repositório contém testes e controles implementados, mas a comprovação integrada Android → Firebase → Central ainda precisa ser concluída e registrada.</a:t>
             </a:r>
           </a:p>
         </p:txBody>
@@ -16677,19 +19034,8 @@
           </a:bodyPr>
           <a:lstStyle xmlns:a="http://schemas.openxmlformats.org/drawingml/2006/main"/>
           <a:p xmlns:a="http://schemas.openxmlformats.org/drawingml/2006/main">
-            <a:pPr algn="l">
-              <a:buNone/>
-              <a:defRPr sz="1100" b="0">
-                <a:solidFill>
-                  <a:srgbClr val="60728A"/>
-                </a:solidFill>
-                <a:latin typeface="Aptos"/>
-                <a:ea typeface="Aptos"/>
-                <a:cs typeface="Aptos"/>
-              </a:defRPr>
-            </a:pPr>
-            <a:r>
-              <a:t>Cadastro e login com e-mail válido</a:t>
+            <a:r>
+              <a:t>Cadastro, login e verificação de e-mail</a:t>
             </a:r>
           </a:p>
         </p:txBody>
@@ -16873,19 +19219,8 @@
           </a:bodyPr>
           <a:lstStyle xmlns:a="http://schemas.openxmlformats.org/drawingml/2006/main"/>
           <a:p xmlns:a="http://schemas.openxmlformats.org/drawingml/2006/main">
-            <a:pPr algn="l">
-              <a:buNone/>
-              <a:defRPr sz="1100" b="0">
-                <a:solidFill>
-                  <a:srgbClr val="60728A"/>
-                </a:solidFill>
-                <a:latin typeface="Aptos"/>
-                <a:ea typeface="Aptos"/>
-                <a:cs typeface="Aptos"/>
-              </a:defRPr>
-            </a:pPr>
-            <a:r>
-              <a:t>Criação e leitura de alertas</a:t>
+            <a:r>
+              <a:t>Regras, auditoria e isolamento institucional</a:t>
             </a:r>
           </a:p>
         </p:txBody>
@@ -17069,19 +19404,8 @@
           </a:bodyPr>
           <a:lstStyle xmlns:a="http://schemas.openxmlformats.org/drawingml/2006/main"/>
           <a:p xmlns:a="http://schemas.openxmlformats.org/drawingml/2006/main">
-            <a:pPr algn="l">
-              <a:buNone/>
-              <a:defRPr sz="1100" b="0">
-                <a:solidFill>
-                  <a:srgbClr val="60728A"/>
-                </a:solidFill>
-                <a:latin typeface="Aptos"/>
-                <a:ea typeface="Aptos"/>
-                <a:cs typeface="Aptos"/>
-              </a:defRPr>
-            </a:pPr>
-            <a:r>
-              <a:t>Envio do alerta com localização</a:t>
+            <a:r>
+              <a:t>SOS com limites locais contra abuso</a:t>
             </a:r>
           </a:p>
         </p:txBody>
@@ -17265,19 +19589,8 @@
           </a:bodyPr>
           <a:lstStyle xmlns:a="http://schemas.openxmlformats.org/drawingml/2006/main"/>
           <a:p xmlns:a="http://schemas.openxmlformats.org/drawingml/2006/main">
-            <a:pPr algn="l">
-              <a:buNone/>
-              <a:defRPr sz="1100" b="0">
-                <a:solidFill>
-                  <a:srgbClr val="60728A"/>
-                </a:solidFill>
-                <a:latin typeface="Aptos"/>
-                <a:ea typeface="Aptos"/>
-                <a:cs typeface="Aptos"/>
-              </a:defRPr>
-            </a:pPr>
-            <a:r>
-              <a:t>Visualização e mudança de status</a:t>
+            <a:r>
+              <a:t>Recebimento, visualização e mudança de status</a:t>
             </a:r>
           </a:p>
         </p:txBody>
@@ -17461,19 +19774,8 @@
           </a:bodyPr>
           <a:lstStyle xmlns:a="http://schemas.openxmlformats.org/drawingml/2006/main"/>
           <a:p xmlns:a="http://schemas.openxmlformats.org/drawingml/2006/main">
-            <a:pPr algn="l">
-              <a:buNone/>
-              <a:defRPr sz="1100" b="0">
-                <a:solidFill>
-                  <a:srgbClr val="60728A"/>
-                </a:solidFill>
-                <a:latin typeface="Aptos"/>
-                <a:ea typeface="Aptos"/>
-                <a:cs typeface="Aptos"/>
-              </a:defRPr>
-            </a:pPr>
-            <a:r>
-              <a:t>GitHub conectado à Vercel</a:t>
+            <a:r>
+              <a:t>Deploy web e CI disponíveis</a:t>
             </a:r>
           </a:p>
         </p:txBody>
@@ -17657,19 +19959,8 @@
           </a:bodyPr>
           <a:lstStyle xmlns:a="http://schemas.openxmlformats.org/drawingml/2006/main"/>
           <a:p xmlns:a="http://schemas.openxmlformats.org/drawingml/2006/main">
-            <a:pPr algn="l">
-              <a:buNone/>
-              <a:defRPr sz="1100" b="0">
-                <a:solidFill>
-                  <a:srgbClr val="60728A"/>
-                </a:solidFill>
-                <a:latin typeface="Aptos"/>
-                <a:ea typeface="Aptos"/>
-                <a:cs typeface="Aptos"/>
-              </a:defRPr>
-            </a:pPr>
-            <a:r>
-              <a:t>Fluxo acessível pelo navegador do celular</a:t>
+            <a:r>
+              <a:t>Modo demonstrativo local disponível</a:t>
             </a:r>
           </a:p>
         </p:txBody>
@@ -17759,19 +20050,8 @@
           </a:bodyPr>
           <a:lstStyle xmlns:a="http://schemas.openxmlformats.org/drawingml/2006/main"/>
           <a:p xmlns:a="http://schemas.openxmlformats.org/drawingml/2006/main">
-            <a:pPr algn="ctr">
-              <a:buNone/>
-              <a:defRPr sz="1200" b="1">
-                <a:solidFill>
-                  <a:srgbClr val="1FA774"/>
-                </a:solidFill>
-                <a:latin typeface="Aptos"/>
-                <a:ea typeface="Aptos"/>
-                <a:cs typeface="Aptos"/>
-              </a:defRPr>
-            </a:pPr>
-            <a:r>
-              <a:t>MVP funcional: integração técnica do fluxo principal concluída.</a:t>
+            <a:r>
+              <a:t>Status correto: protótipo acadêmico avançado e MVP demonstrativo em desenvolvimento, ainda dependente de validação integrada.</a:t>
             </a:r>
           </a:p>
         </p:txBody>

</xml_diff>

<commit_message>
docs: adicionar autoria e responsabilidade geral na apresentacao
</commit_message>
<xml_diff>
--- a/UniGuard_Apresentacao_Profissional_Atualizada.pptx
+++ b/UniGuard_Apresentacao_Profissional_Atualizada.pptx
@@ -23,6 +23,7 @@
     <p:sldId xmlns:ns0="http://schemas.openxmlformats.org/officeDocument/2006/relationships" id="268" ns0:id="rId19"/>
     <p:sldId xmlns:ns0="http://schemas.openxmlformats.org/officeDocument/2006/relationships" id="269" ns0:id="rId20"/>
     <p:sldId xmlns:ns0="http://schemas.openxmlformats.org/officeDocument/2006/relationships" id="270" ns0:id="rId21"/>
+    <p:sldId xmlns:ns0="http://schemas.openxmlformats.org/officeDocument/2006/relationships" id="271" ns0:id="rId22"/>
   </p:sldIdLst>
   <p:sldSz cx="12191695" cy="6858000"/>
   <p:notesSz cx="6858000" cy="9144000"/>
@@ -11057,6 +11058,565 @@
 </p:sld>
 </file>
 
+<file path=ppt/slides/slide16.xml><?xml version="1.0" encoding="utf-8"?>
+<p:sld xmlns:a="http://schemas.openxmlformats.org/drawingml/2006/main" xmlns:p="http://schemas.openxmlformats.org/presentationml/2006/main" xmlns:r="http://schemas.openxmlformats.org/officeDocument/2006/relationships">
+  <p:cSld>
+    <p:bg>
+      <p:bgPr>
+        <a:solidFill>
+          <a:srgbClr val="0B2E4D"/>
+        </a:solidFill>
+        <a:effectLst/>
+      </p:bgPr>
+    </p:bg>
+    <p:spTree>
+      <p:nvGrpSpPr>
+        <p:cNvPr id="1" name=""/>
+        <p:cNvGrpSpPr/>
+        <p:nvPr/>
+      </p:nvGrpSpPr>
+      <p:grpSpPr/>
+      <p:sp>
+        <p:nvSpPr>
+          <p:cNvPr id="2" name="Rectangle 1"/>
+          <p:cNvSpPr/>
+          <p:nvPr/>
+        </p:nvSpPr>
+        <p:spPr>
+          <a:xfrm>
+            <a:off x="8366760" y="0"/>
+            <a:ext cx="3840480" cy="6858000"/>
+          </a:xfrm>
+          <a:prstGeom prst="rect">
+            <a:avLst/>
+          </a:prstGeom>
+          <a:solidFill>
+            <a:srgbClr val="07253E"/>
+          </a:solidFill>
+          <a:ln>
+            <a:noFill/>
+          </a:ln>
+        </p:spPr>
+        <p:style>
+          <a:lnRef idx="1">
+            <a:schemeClr val="accent1"/>
+          </a:lnRef>
+          <a:fillRef idx="3">
+            <a:schemeClr val="accent1"/>
+          </a:fillRef>
+          <a:effectRef idx="2">
+            <a:schemeClr val="accent1"/>
+          </a:effectRef>
+          <a:fontRef idx="minor">
+            <a:schemeClr val="lt1"/>
+          </a:fontRef>
+        </p:style>
+        <p:txBody>
+          <a:bodyPr rtlCol="0" anchor="ctr"/>
+          <a:lstStyle/>
+          <a:p>
+            <a:pPr algn="ctr"/>
+          </a:p>
+        </p:txBody>
+      </p:sp>
+      <p:sp>
+        <p:nvSpPr>
+          <p:cNvPr id="3" name="Rectangle 2"/>
+          <p:cNvSpPr/>
+          <p:nvPr/>
+        </p:nvSpPr>
+        <p:spPr>
+          <a:xfrm>
+            <a:off x="594360" y="594360"/>
+            <a:ext cx="1508760" cy="45720"/>
+          </a:xfrm>
+          <a:prstGeom prst="rect">
+            <a:avLst/>
+          </a:prstGeom>
+          <a:solidFill>
+            <a:srgbClr val="12B5CB"/>
+          </a:solidFill>
+          <a:ln>
+            <a:noFill/>
+          </a:ln>
+        </p:spPr>
+        <p:style>
+          <a:lnRef idx="1">
+            <a:schemeClr val="accent1"/>
+          </a:lnRef>
+          <a:fillRef idx="3">
+            <a:schemeClr val="accent1"/>
+          </a:fillRef>
+          <a:effectRef idx="2">
+            <a:schemeClr val="accent1"/>
+          </a:effectRef>
+          <a:fontRef idx="minor">
+            <a:schemeClr val="lt1"/>
+          </a:fontRef>
+        </p:style>
+        <p:txBody>
+          <a:bodyPr rtlCol="0" anchor="ctr"/>
+          <a:lstStyle/>
+          <a:p>
+            <a:pPr algn="ctr"/>
+          </a:p>
+        </p:txBody>
+      </p:sp>
+      <p:sp>
+        <p:nvSpPr>
+          <p:cNvPr id="4" name="Oval 3"/>
+          <p:cNvSpPr/>
+          <p:nvPr/>
+        </p:nvSpPr>
+        <p:spPr>
+          <a:xfrm>
+            <a:off x="8732520" y="1005840"/>
+            <a:ext cx="2651760" cy="2651760"/>
+          </a:xfrm>
+          <a:prstGeom prst="ellipse">
+            <a:avLst/>
+          </a:prstGeom>
+          <a:solidFill>
+            <a:srgbClr val="073A5C"/>
+          </a:solidFill>
+          <a:ln>
+            <a:noFill/>
+          </a:ln>
+        </p:spPr>
+        <p:style>
+          <a:lnRef idx="1">
+            <a:schemeClr val="accent1"/>
+          </a:lnRef>
+          <a:fillRef idx="3">
+            <a:schemeClr val="accent1"/>
+          </a:fillRef>
+          <a:effectRef idx="2">
+            <a:schemeClr val="accent1"/>
+          </a:effectRef>
+          <a:fontRef idx="minor">
+            <a:schemeClr val="lt1"/>
+          </a:fontRef>
+        </p:style>
+        <p:txBody>
+          <a:bodyPr rtlCol="0" anchor="ctr"/>
+          <a:lstStyle/>
+          <a:p>
+            <a:pPr algn="ctr"/>
+          </a:p>
+        </p:txBody>
+      </p:sp>
+      <p:sp>
+        <p:nvSpPr>
+          <p:cNvPr id="5" name="Oval 4"/>
+          <p:cNvSpPr/>
+          <p:nvPr/>
+        </p:nvSpPr>
+        <p:spPr>
+          <a:xfrm>
+            <a:off x="9189720" y="1463040"/>
+            <a:ext cx="1737360" cy="1737360"/>
+          </a:xfrm>
+          <a:prstGeom prst="ellipse">
+            <a:avLst/>
+          </a:prstGeom>
+          <a:solidFill>
+            <a:srgbClr val="12B5CB"/>
+          </a:solidFill>
+          <a:ln>
+            <a:noFill/>
+          </a:ln>
+        </p:spPr>
+        <p:style>
+          <a:lnRef idx="1">
+            <a:schemeClr val="accent1"/>
+          </a:lnRef>
+          <a:fillRef idx="3">
+            <a:schemeClr val="accent1"/>
+          </a:fillRef>
+          <a:effectRef idx="2">
+            <a:schemeClr val="accent1"/>
+          </a:effectRef>
+          <a:fontRef idx="minor">
+            <a:schemeClr val="lt1"/>
+          </a:fontRef>
+        </p:style>
+        <p:txBody>
+          <a:bodyPr rtlCol="0" anchor="ctr"/>
+          <a:lstStyle/>
+          <a:p>
+            <a:pPr algn="ctr"/>
+          </a:p>
+        </p:txBody>
+      </p:sp>
+      <p:sp>
+        <p:nvSpPr>
+          <p:cNvPr id="6" name="TextBox 5"/>
+          <p:cNvSpPr txBox="1"/>
+          <p:nvPr/>
+        </p:nvSpPr>
+        <p:spPr>
+          <a:xfrm>
+            <a:off x="594360" y="786384"/>
+            <a:ext cx="5029200" cy="320040"/>
+          </a:xfrm>
+          <a:prstGeom prst="rect">
+            <a:avLst/>
+          </a:prstGeom>
+          <a:noFill/>
+        </p:spPr>
+        <p:txBody>
+          <a:bodyPr wrap="square">
+            <a:spAutoFit/>
+          </a:bodyPr>
+          <a:lstStyle/>
+          <a:p>
+            <a:pPr algn="l"/>
+            <a:r>
+              <a:rPr sz="1000" b="1">
+                <a:solidFill>
+                  <a:srgbClr val="12B5CB"/>
+                </a:solidFill>
+                <a:latin typeface="Aptos"/>
+              </a:rPr>
+              <a:t>AUTORIA E RESPONSABILIDADE GERAL</a:t>
+            </a:r>
+          </a:p>
+        </p:txBody>
+      </p:sp>
+      <p:sp>
+        <p:nvSpPr>
+          <p:cNvPr id="7" name="TextBox 6"/>
+          <p:cNvSpPr txBox="1"/>
+          <p:nvPr/>
+        </p:nvSpPr>
+        <p:spPr>
+          <a:xfrm>
+            <a:off x="594360" y="1325880"/>
+            <a:ext cx="6949440" cy="731520"/>
+          </a:xfrm>
+          <a:prstGeom prst="rect">
+            <a:avLst/>
+          </a:prstGeom>
+          <a:noFill/>
+        </p:spPr>
+        <p:txBody>
+          <a:bodyPr wrap="square">
+            <a:spAutoFit/>
+          </a:bodyPr>
+          <a:lstStyle/>
+          <a:p>
+            <a:pPr algn="l"/>
+            <a:r>
+              <a:rPr sz="3400" b="1">
+                <a:solidFill>
+                  <a:srgbClr val="FFFFFF"/>
+                </a:solidFill>
+                <a:latin typeface="Aptos"/>
+              </a:rPr>
+              <a:t>Priscilla Cahino</a:t>
+            </a:r>
+          </a:p>
+        </p:txBody>
+      </p:sp>
+      <p:sp>
+        <p:nvSpPr>
+          <p:cNvPr id="8" name="TextBox 7"/>
+          <p:cNvSpPr txBox="1"/>
+          <p:nvPr/>
+        </p:nvSpPr>
+        <p:spPr>
+          <a:xfrm>
+            <a:off x="594360" y="1993392"/>
+            <a:ext cx="7223760" cy="457200"/>
+          </a:xfrm>
+          <a:prstGeom prst="rect">
+            <a:avLst/>
+          </a:prstGeom>
+          <a:noFill/>
+        </p:spPr>
+        <p:txBody>
+          <a:bodyPr wrap="square">
+            <a:spAutoFit/>
+          </a:bodyPr>
+          <a:lstStyle/>
+          <a:p>
+            <a:pPr algn="l"/>
+            <a:r>
+              <a:rPr sz="1700" b="1">
+                <a:solidFill>
+                  <a:srgbClr val="DAEFF6"/>
+                </a:solidFill>
+                <a:latin typeface="Aptos"/>
+              </a:rPr>
+              <a:t>Responsável geral pelo projeto UniGuard</a:t>
+            </a:r>
+          </a:p>
+        </p:txBody>
+      </p:sp>
+      <p:sp>
+        <p:nvSpPr>
+          <p:cNvPr id="9" name="TextBox 8"/>
+          <p:cNvSpPr txBox="1"/>
+          <p:nvPr/>
+        </p:nvSpPr>
+        <p:spPr>
+          <a:xfrm>
+            <a:off x="594360" y="2788920"/>
+            <a:ext cx="6995160" cy="1097280"/>
+          </a:xfrm>
+          <a:prstGeom prst="rect">
+            <a:avLst/>
+          </a:prstGeom>
+          <a:noFill/>
+        </p:spPr>
+        <p:txBody>
+          <a:bodyPr wrap="square">
+            <a:spAutoFit/>
+          </a:bodyPr>
+          <a:lstStyle/>
+          <a:p>
+            <a:pPr algn="l"/>
+            <a:r>
+              <a:rPr sz="1400" b="0">
+                <a:solidFill>
+                  <a:srgbClr val="DFE9F1"/>
+                </a:solidFill>
+                <a:latin typeface="Aptos"/>
+              </a:rPr>
+              <a:t>Atuação responsável pela idealização, concepção do produto, definição da proposta de valor, estruturação dos fluxos, requisitos, regras de negócio, prototipação, documentação, organização dos artefatos e consolidação da apresentação profissional do projeto.</a:t>
+            </a:r>
+          </a:p>
+        </p:txBody>
+      </p:sp>
+      <p:sp>
+        <p:nvSpPr>
+          <p:cNvPr id="10" name="Rounded Rectangle 9"/>
+          <p:cNvSpPr/>
+          <p:nvPr/>
+        </p:nvSpPr>
+        <p:spPr>
+          <a:xfrm>
+            <a:off x="594360" y="4343400"/>
+            <a:ext cx="7086600" cy="1097280"/>
+          </a:xfrm>
+          <a:prstGeom prst="roundRect">
+            <a:avLst/>
+          </a:prstGeom>
+          <a:solidFill>
+            <a:srgbClr val="0F4168"/>
+          </a:solidFill>
+          <a:ln>
+            <a:solidFill>
+              <a:srgbClr val="266288"/>
+            </a:solidFill>
+          </a:ln>
+        </p:spPr>
+        <p:style>
+          <a:lnRef idx="1">
+            <a:schemeClr val="accent1"/>
+          </a:lnRef>
+          <a:fillRef idx="3">
+            <a:schemeClr val="accent1"/>
+          </a:fillRef>
+          <a:effectRef idx="2">
+            <a:schemeClr val="accent1"/>
+          </a:effectRef>
+          <a:fontRef idx="minor">
+            <a:schemeClr val="lt1"/>
+          </a:fontRef>
+        </p:style>
+        <p:txBody>
+          <a:bodyPr rtlCol="0" anchor="ctr"/>
+          <a:lstStyle/>
+          <a:p>
+            <a:pPr algn="ctr"/>
+          </a:p>
+        </p:txBody>
+      </p:sp>
+      <p:sp>
+        <p:nvSpPr>
+          <p:cNvPr id="11" name="TextBox 10"/>
+          <p:cNvSpPr txBox="1"/>
+          <p:nvPr/>
+        </p:nvSpPr>
+        <p:spPr>
+          <a:xfrm>
+            <a:off x="868680" y="4590288"/>
+            <a:ext cx="6537960" cy="566928"/>
+          </a:xfrm>
+          <a:prstGeom prst="rect">
+            <a:avLst/>
+          </a:prstGeom>
+          <a:noFill/>
+        </p:spPr>
+        <p:txBody>
+          <a:bodyPr wrap="square">
+            <a:spAutoFit/>
+          </a:bodyPr>
+          <a:lstStyle/>
+          <a:p>
+            <a:pPr algn="l"/>
+            <a:r>
+              <a:rPr sz="1300" b="0">
+                <a:solidFill>
+                  <a:srgbClr val="E5F0F6"/>
+                </a:solidFill>
+                <a:latin typeface="Aptos"/>
+              </a:rPr>
+              <a:t>Projeto acadêmico e tecnológico em evolução, com finalidade demonstrativa e base documental alinhada ao repositório GitHub.</a:t>
+            </a:r>
+          </a:p>
+        </p:txBody>
+      </p:sp>
+      <p:sp>
+        <p:nvSpPr>
+          <p:cNvPr id="12" name="TextBox 11"/>
+          <p:cNvSpPr txBox="1"/>
+          <p:nvPr/>
+        </p:nvSpPr>
+        <p:spPr>
+          <a:xfrm>
+            <a:off x="8823960" y="3931920"/>
+            <a:ext cx="2286000" cy="320040"/>
+          </a:xfrm>
+          <a:prstGeom prst="rect">
+            <a:avLst/>
+          </a:prstGeom>
+          <a:noFill/>
+        </p:spPr>
+        <p:txBody>
+          <a:bodyPr wrap="square">
+            <a:spAutoFit/>
+          </a:bodyPr>
+          <a:lstStyle/>
+          <a:p>
+            <a:pPr algn="ctr"/>
+            <a:r>
+              <a:rPr sz="1100" b="1">
+                <a:solidFill>
+                  <a:srgbClr val="12B5CB"/>
+                </a:solidFill>
+                <a:latin typeface="Aptos"/>
+              </a:rPr>
+              <a:t>UNIGUARD</a:t>
+            </a:r>
+          </a:p>
+        </p:txBody>
+      </p:sp>
+      <p:sp>
+        <p:nvSpPr>
+          <p:cNvPr id="13" name="TextBox 12"/>
+          <p:cNvSpPr txBox="1"/>
+          <p:nvPr/>
+        </p:nvSpPr>
+        <p:spPr>
+          <a:xfrm>
+            <a:off x="8549640" y="4343400"/>
+            <a:ext cx="2834640" cy="731520"/>
+          </a:xfrm>
+          <a:prstGeom prst="rect">
+            <a:avLst/>
+          </a:prstGeom>
+          <a:noFill/>
+        </p:spPr>
+        <p:txBody>
+          <a:bodyPr wrap="square">
+            <a:spAutoFit/>
+          </a:bodyPr>
+          <a:lstStyle/>
+          <a:p>
+            <a:pPr algn="ctr"/>
+            <a:r>
+              <a:rPr sz="1800" b="1">
+                <a:solidFill>
+                  <a:srgbClr val="FFFFFF"/>
+                </a:solidFill>
+                <a:latin typeface="Aptos"/>
+              </a:rPr>
+              <a:t>Segurança universitária
+conectada ao cuidado</a:t>
+            </a:r>
+          </a:p>
+        </p:txBody>
+      </p:sp>
+      <p:sp>
+        <p:nvSpPr>
+          <p:cNvPr id="14" name="TextBox 13"/>
+          <p:cNvSpPr txBox="1"/>
+          <p:nvPr/>
+        </p:nvSpPr>
+        <p:spPr>
+          <a:xfrm>
+            <a:off x="594360" y="6327648"/>
+            <a:ext cx="4846320" cy="228600"/>
+          </a:xfrm>
+          <a:prstGeom prst="rect">
+            <a:avLst/>
+          </a:prstGeom>
+          <a:noFill/>
+        </p:spPr>
+        <p:txBody>
+          <a:bodyPr wrap="square">
+            <a:spAutoFit/>
+          </a:bodyPr>
+          <a:lstStyle/>
+          <a:p>
+            <a:pPr algn="l"/>
+            <a:r>
+              <a:rPr sz="800" b="0">
+                <a:solidFill>
+                  <a:srgbClr val="ADBCCA"/>
+                </a:solidFill>
+                <a:latin typeface="Aptos"/>
+              </a:rPr>
+              <a:t>PROTÓTIPO ACADÊMICO • DADOS DEMONSTRATIVOS</a:t>
+            </a:r>
+          </a:p>
+        </p:txBody>
+      </p:sp>
+      <p:sp>
+        <p:nvSpPr>
+          <p:cNvPr id="15" name="TextBox 14"/>
+          <p:cNvSpPr txBox="1"/>
+          <p:nvPr/>
+        </p:nvSpPr>
+        <p:spPr>
+          <a:xfrm>
+            <a:off x="10716768" y="6291072"/>
+            <a:ext cx="411480" cy="228600"/>
+          </a:xfrm>
+          <a:prstGeom prst="rect">
+            <a:avLst/>
+          </a:prstGeom>
+          <a:noFill/>
+        </p:spPr>
+        <p:txBody>
+          <a:bodyPr wrap="square">
+            <a:spAutoFit/>
+          </a:bodyPr>
+          <a:lstStyle/>
+          <a:p>
+            <a:pPr algn="r"/>
+            <a:r>
+              <a:rPr sz="800" b="0">
+                <a:solidFill>
+                  <a:srgbClr val="ADBCCA"/>
+                </a:solidFill>
+                <a:latin typeface="Aptos"/>
+              </a:rPr>
+              <a:t>16</a:t>
+            </a:r>
+          </a:p>
+        </p:txBody>
+      </p:sp>
+    </p:spTree>
+  </p:cSld>
+  <p:clrMapOvr>
+    <a:masterClrMapping/>
+  </p:clrMapOvr>
+</p:sld>
+</file>
+
 <file path=ppt/slides/slide2.xml><?xml version="1.0" encoding="utf-8"?>
 <p:sld xmlns:p="http://schemas.openxmlformats.org/presentationml/2006/main">
   <p:cSld>

</xml_diff>